<commit_message>
Wk3 decks: plain titles, Day 1 network/who-gets-called flow, trim captions
Co-Authored-By: Claude Fable 5.1 <noreply@anthropic.com>

Claude-Session: https://claude.ai/code/session_01SqDy6J893cToNQakgX717Q
</commit_message>
<xml_diff>
--- a/docs/resources/slides/1sw-wk3-day1.pptx
+++ b/docs/resources/slides/1sw-wk3-day1.pptx
@@ -14,9 +14,11 @@
     <p:sldId id="262" r:id="rId8"/>
     <p:sldId id="263" r:id="rId9"/>
     <p:sldId id="264" r:id="rId10"/>
+    <p:sldId id="265" r:id="rId11"/>
+    <p:sldId id="266" r:id="rId12"/>
   </p:sldIdLst>
   <p:notesMasterIdLst>
-    <p:notesMasterId r:id="rId11"/>
+    <p:notesMasterId r:id="rId13"/>
   </p:notesMasterIdLst>
   <p:sldSz cx="12191695" cy="6858000"/>
   <p:notesSz cx="6858000" cy="12191695"/>
@@ -554,6 +556,186 @@
 </p:notes>
 </file>
 
+<file path=ppt/notesSlides/notesSlide10.xml><?xml version="1.0" encoding="utf-8"?>
+<p:notes xmlns:a="http://schemas.openxmlformats.org/drawingml/2006/main" xmlns:r="http://schemas.openxmlformats.org/officeDocument/2006/relationships" xmlns:p="http://schemas.openxmlformats.org/presentationml/2006/main">
+  <p:cSld>
+    <p:spTree>
+      <p:nvGrpSpPr>
+        <p:cNvPr id="1" name=""/>
+        <p:cNvGrpSpPr/>
+        <p:nvPr/>
+      </p:nvGrpSpPr>
+      <p:grpSpPr>
+        <a:xfrm>
+          <a:off x="0" y="0"/>
+          <a:ext cx="0" cy="0"/>
+          <a:chOff x="0" y="0"/>
+          <a:chExt cx="0" cy="0"/>
+        </a:xfrm>
+      </p:grpSpPr>
+      <p:sp>
+        <p:nvSpPr>
+          <p:cNvPr id="2" name="Slide Image Placeholder 1"/>
+          <p:cNvSpPr>
+            <a:spLocks noGrp="1" noRot="1" noChangeAspect="1"/>
+          </p:cNvSpPr>
+          <p:nvPr>
+            <p:ph type="sldImg"/>
+          </p:nvPr>
+        </p:nvSpPr>
+        <p:spPr/>
+      </p:sp>
+      <p:sp>
+        <p:nvSpPr>
+          <p:cNvPr id="3" name="Notes Placeholder 2"/>
+          <p:cNvSpPr>
+            <a:spLocks noGrp="1"/>
+          </p:cNvSpPr>
+          <p:nvPr>
+            <p:ph type="body" idx="1"/>
+          </p:nvPr>
+        </p:nvSpPr>
+        <p:spPr/>
+        <p:txBody>
+          <a:bodyPr/>
+          <a:lstStyle/>
+          <a:p>
+            <a:r>
+              <a:rPr lang="en-US" dirty="0"/>
+              <a:t>42-50 min. The button opens a copy of the Venn Doc. The middle must be soft skills; a student who writes 'coding' in the middle has the wrong idea about transfer. Grade the bottom line, not the count.
+[Sources]
+Canvas page renders of CCE course 98060 student pages, captured 2026-09-15.</a:t>
+            </a:r>
+            <a:endParaRPr lang="en-US" dirty="0"/>
+          </a:p>
+        </p:txBody>
+      </p:sp>
+      <p:sp>
+        <p:nvSpPr>
+          <p:cNvPr id="4" name="Slide Number Placeholder 3"/>
+          <p:cNvSpPr>
+            <a:spLocks noGrp="1"/>
+          </p:cNvSpPr>
+          <p:nvPr>
+            <p:ph type="sldNum" sz="quarter" idx="10"/>
+          </p:nvPr>
+        </p:nvSpPr>
+        <p:spPr/>
+        <p:txBody>
+          <a:bodyPr/>
+          <a:lstStyle/>
+          <a:p>
+            <a:fld id="{F7021451-1387-4CA6-816F-3879F97B5CBC}" type="slidenum">
+              <a:rPr lang="en-US"/>
+              <a:t>10</a:t>
+            </a:fld>
+            <a:endParaRPr lang="en-US"/>
+          </a:p>
+        </p:txBody>
+      </p:sp>
+    </p:spTree>
+    <p:extLst>
+      <p:ext uri="{BB962C8B-B14F-4D97-AF65-F5344CB8AC3E}">
+        <p14:creationId xmlns:p14="http://schemas.microsoft.com/office/powerpoint/2010/main" val="1024086991"/>
+      </p:ext>
+    </p:extLst>
+  </p:cSld>
+  <p:clrMapOvr>
+    <a:masterClrMapping/>
+  </p:clrMapOvr>
+</p:notes>
+</file>
+
+<file path=ppt/notesSlides/notesSlide11.xml><?xml version="1.0" encoding="utf-8"?>
+<p:notes xmlns:a="http://schemas.openxmlformats.org/drawingml/2006/main" xmlns:r="http://schemas.openxmlformats.org/officeDocument/2006/relationships" xmlns:p="http://schemas.openxmlformats.org/presentationml/2006/main">
+  <p:cSld>
+    <p:spTree>
+      <p:nvGrpSpPr>
+        <p:cNvPr id="1" name=""/>
+        <p:cNvGrpSpPr/>
+        <p:nvPr/>
+      </p:nvGrpSpPr>
+      <p:grpSpPr>
+        <a:xfrm>
+          <a:off x="0" y="0"/>
+          <a:ext cx="0" cy="0"/>
+          <a:chOff x="0" y="0"/>
+          <a:chExt cx="0" cy="0"/>
+        </a:xfrm>
+      </p:grpSpPr>
+      <p:sp>
+        <p:nvSpPr>
+          <p:cNvPr id="2" name="Slide Image Placeholder 1"/>
+          <p:cNvSpPr>
+            <a:spLocks noGrp="1" noRot="1" noChangeAspect="1"/>
+          </p:cNvSpPr>
+          <p:nvPr>
+            <p:ph type="sldImg"/>
+          </p:nvPr>
+        </p:nvSpPr>
+        <p:spPr/>
+      </p:sp>
+      <p:sp>
+        <p:nvSpPr>
+          <p:cNvPr id="3" name="Notes Placeholder 2"/>
+          <p:cNvSpPr>
+            <a:spLocks noGrp="1"/>
+          </p:cNvSpPr>
+          <p:nvPr>
+            <p:ph type="body" idx="1"/>
+          </p:nvPr>
+        </p:nvSpPr>
+        <p:spPr/>
+        <p:txBody>
+          <a:bodyPr/>
+          <a:lstStyle/>
+          <a:p>
+            <a:r>
+              <a:rPr lang="en-US" dirty="0"/>
+              <a:t>Last minute. Chromebooks docked. Keep the card sets if students wrote on them; they are Day 1 evidence.
+[Sources]
+Networking Career Cards (CCE-authored, build/worksheet_sources/wk3-networking-career-cards.md; BLS OOH accessed 2026-08-09).</a:t>
+            </a:r>
+            <a:endParaRPr lang="en-US" dirty="0"/>
+          </a:p>
+        </p:txBody>
+      </p:sp>
+      <p:sp>
+        <p:nvSpPr>
+          <p:cNvPr id="4" name="Slide Number Placeholder 3"/>
+          <p:cNvSpPr>
+            <a:spLocks noGrp="1"/>
+          </p:cNvSpPr>
+          <p:nvPr>
+            <p:ph type="sldNum" sz="quarter" idx="10"/>
+          </p:nvPr>
+        </p:nvSpPr>
+        <p:spPr/>
+        <p:txBody>
+          <a:bodyPr/>
+          <a:lstStyle/>
+          <a:p>
+            <a:fld id="{F7021451-1387-4CA6-816F-3879F97B5CBC}" type="slidenum">
+              <a:rPr lang="en-US"/>
+              <a:t>11</a:t>
+            </a:fld>
+            <a:endParaRPr lang="en-US"/>
+          </a:p>
+        </p:txBody>
+      </p:sp>
+    </p:spTree>
+    <p:extLst>
+      <p:ext uri="{BB962C8B-B14F-4D97-AF65-F5344CB8AC3E}">
+        <p14:creationId xmlns:p14="http://schemas.microsoft.com/office/powerpoint/2010/main" val="1024086991"/>
+      </p:ext>
+    </p:extLst>
+  </p:cSld>
+  <p:clrMapOvr>
+    <a:masterClrMapping/>
+  </p:clrMapOvr>
+</p:notes>
+</file>
+
 <file path=ppt/notesSlides/notesSlide2.xml><?xml version="1.0" encoding="utf-8"?>
 <p:notes xmlns:a="http://schemas.openxmlformats.org/drawingml/2006/main" xmlns:r="http://schemas.openxmlformats.org/officeDocument/2006/relationships" xmlns:p="http://schemas.openxmlformats.org/presentationml/2006/main">
   <p:cSld>
@@ -780,9 +962,9 @@
           <a:p>
             <a:r>
               <a:rPr lang="en-US" dirty="0"/>
-              <a:t>5-9 min. Read the four cards once. Do not put salary numbers on the board today; the cards carry tasks and preparation only, and the exact salary work happens on Day 4 with dated figures. The BLS page shown is the source for the Network Administrator card.
+              <a:t>5-7 min. Read the definition once, then connect it to the warm-up: the Wi-Fi checklist students just made is the network. The four people who get called are the next slide.
 [Sources]
-Networking Career Cards (CCE-authored, build/worksheet_sources/wk3-networking-career-cards.md; BLS OOH accessed 2026-08-09). U.S. Bureau of Labor Statistics, Occupational Outlook Handbook, "Network and Computer Systems Administrators" (https://www.bls.gov/ooh/computer-and-information-technology/network-and-computer-systems-administrators.htm), screenshot captured 2026-09-15. Public domain.</a:t>
+Definition: docs/1sw/wk3-computer-science-it/overview.md vocabulary. U.S. Bureau of Labor Statistics, Occupational Outlook Handbook, "Network and Computer Systems Administrators" (https://www.bls.gov/ooh/computer-and-information-technology/network-and-computer-systems-administrators.htm), screenshot captured 2026-09-15. Public domain.</a:t>
             </a:r>
             <a:endParaRPr lang="en-US" dirty="0"/>
           </a:p>
@@ -870,9 +1052,9 @@
           <a:p>
             <a:r>
               <a:rPr lang="en-US" dirty="0"/>
-              <a:t>9-31 min. Four rows, one per career. Lap 1 at minute 8: every student has a task verb for two careers. Lap 2 at minute 18: the skill column says why, not just the skill name. Students who record on the printed cards or in the notebook both count; use the response route your class set up in Week 0. The ten-skill list Doc is linked on the Day 1 page for students who want more choices than the seven on this slide.
+              <a:t>7-10 min. Read the four cards once. No salary numbers on the board today; the cards carry tasks and preparation only, and the salary work happens on Day 4 with dated figures. The BLS page shown is the source for the Network Administrator card. The cards say 'typical preparation'; if a student asks, typical means common, not required by every employer.
 [Sources]
-Networking Career Cards (CCE-authored, build/worksheet_sources/wk3-networking-career-cards.md; BLS OOH accessed 2026-08-09). Canvas page renders of CCE course 98060 student pages, captured 2026-09-15. Find Your Future (Irving ISD / Hats &amp; Ladders, ©2026), printed pp. 38; district-licensed workbook page images from the CCE Canvas course, not for public distribution.</a:t>
+Networking Career Cards (CCE-authored, build/worksheet_sources/wk3-networking-career-cards.md; BLS OOH accessed 2026-08-09). U.S. Bureau of Labor Statistics, Occupational Outlook Handbook, "Network and Computer Systems Administrators" (https://www.bls.gov/ooh/computer-and-information-technology/network-and-computer-systems-administrators.htm), screenshot captured 2026-09-15. Public domain.</a:t>
             </a:r>
             <a:endParaRPr lang="en-US" dirty="0"/>
           </a:p>
@@ -960,7 +1142,7 @@
           <a:p>
             <a:r>
               <a:rPr lang="en-US" dirty="0"/>
-              <a:t>31-34 min. One minute of teaching before the jot. Ask for one example of each from a student's own row before moving on.
+              <a:t>10-12 min. Fast. Administrator first, Architect designed it, Database Administrator watches the data. A wrong answer with a reason from the card is fine; that is the compare task starting early.
 [Sources]
 Networking Career Cards (CCE-authored, build/worksheet_sources/wk3-networking-career-cards.md; BLS OOH accessed 2026-08-09).</a:t>
             </a:r>
@@ -1050,9 +1232,9 @@
           <a:p>
             <a:r>
               <a:rPr lang="en-US" dirty="0"/>
-              <a:t>34-46 min including the discussion. 60 seconds silent, then three students read their sentence. Listen for the 'because' clause; a sentence without it is two job titles and a skill name. Board capture: write each skill students name and tally repeats. That tally is what the exit-ticket Venn draws from.
+              <a:t>12-31 min. Four rows, one per career. Lap 1 at minute 8: every student has a task verb for two careers. Lap 2 at minute 18: the skill column says why, not just the skill name. Students who record on the printed cards or in the notebook both count; use the response route your class set up in Week 0. The ten-skill list Doc is linked on the Day 1 page for students who want more choices than the seven on this slide.
 [Sources]
-Networking Career Cards (CCE-authored, build/worksheet_sources/wk3-networking-career-cards.md; BLS OOH accessed 2026-08-09).</a:t>
+Networking Career Cards (CCE-authored, build/worksheet_sources/wk3-networking-career-cards.md; BLS OOH accessed 2026-08-09). Canvas page renders of CCE course 98060 student pages, captured 2026-09-15. Find Your Future (Irving ISD / Hats &amp; Ladders, ©2026), printed pp. 38; district-licensed workbook page images from the CCE Canvas course, not for public distribution.</a:t>
             </a:r>
             <a:endParaRPr lang="en-US" dirty="0"/>
           </a:p>
@@ -1140,9 +1322,9 @@
           <a:p>
             <a:r>
               <a:rPr lang="en-US" dirty="0"/>
-              <a:t>42-50 min. The button opens a copy of the Venn Doc. The middle must be soft skills; a student who writes 'coding' in the middle has the wrong idea about transfer. Grade the bottom line, not the count.
+              <a:t>31-34 min. One minute of teaching before the jot. Ask for one example of each from a student's own row before moving on.
 [Sources]
-Canvas page renders of CCE course 98060 student pages, captured 2026-09-15.</a:t>
+Networking Career Cards (CCE-authored, build/worksheet_sources/wk3-networking-career-cards.md; BLS OOH accessed 2026-08-09).</a:t>
             </a:r>
             <a:endParaRPr lang="en-US" dirty="0"/>
           </a:p>
@@ -1230,7 +1412,7 @@
           <a:p>
             <a:r>
               <a:rPr lang="en-US" dirty="0"/>
-              <a:t>Last minute. Chromebooks docked. Keep the card sets if students wrote on them; they are Day 1 evidence.
+              <a:t>34-46 min including the discussion. 60 seconds silent, then three students read their sentence. Listen for the 'because' clause; a sentence without it is two job titles and a skill name. Board capture: write each skill students name and tally repeats. That tally is what the exit-ticket Venn draws from.
 [Sources]
 Networking Career Cards (CCE-authored, build/worksheet_sources/wk3-networking-career-cards.md; BLS OOH accessed 2026-08-09).</a:t>
             </a:r>
@@ -1638,7 +1820,7 @@
                 <a:ea typeface="Arial Black" pitchFamily="34" charset="-122"/>
                 <a:cs typeface="Arial Black" pitchFamily="34" charset="-120"/>
               </a:rPr>
-              <a:t>Who keeps the Wi-Fi up?</a:t>
+              <a:t>Networking careers</a:t>
             </a:r>
             <a:endParaRPr lang="en-US" sz="6000" dirty="0"/>
           </a:p>
@@ -1677,7 +1859,7 @@
                 <a:ea typeface="Arial" pitchFamily="34" charset="-122"/>
                 <a:cs typeface="Arial" pitchFamily="34" charset="-120"/>
               </a:rPr>
-              <a:t>Networking and data careers.</a:t>
+              <a:t>Who keeps the Wi-Fi up?</a:t>
             </a:r>
             <a:endParaRPr lang="en-US" sz="3000" dirty="0"/>
           </a:p>
@@ -1758,6 +1940,922 @@
               <a:t>Bring your notebook, a pencil, and your Chromebook. Find Your Future workbook only if you finish early (p. 38).</a:t>
             </a:r>
             <a:endParaRPr lang="en-US" sz="2000" dirty="0"/>
+          </a:p>
+        </p:txBody>
+      </p:sp>
+    </p:spTree>
+  </p:cSld>
+  <p:clrMapOvr>
+    <a:masterClrMapping/>
+  </p:clrMapOvr>
+</p:sld>
+</file>
+
+<file path=ppt/slides/slide10.xml><?xml version="1.0" encoding="utf-8"?>
+<p:sld xmlns:a="http://schemas.openxmlformats.org/drawingml/2006/main" xmlns:r="http://schemas.openxmlformats.org/officeDocument/2006/relationships" xmlns:p="http://schemas.openxmlformats.org/presentationml/2006/main">
+  <p:cSld name="Slide 10">
+    <p:bg>
+      <p:bgPr>
+        <a:solidFill>
+          <a:srgbClr val="FAF7EF"/>
+        </a:solidFill>
+      </p:bgPr>
+    </p:bg>
+    <p:spTree>
+      <p:nvGrpSpPr>
+        <p:cNvPr id="1" name=""/>
+        <p:cNvGrpSpPr/>
+        <p:nvPr/>
+      </p:nvGrpSpPr>
+      <p:grpSpPr>
+        <a:xfrm>
+          <a:off x="0" y="0"/>
+          <a:ext cx="0" cy="0"/>
+          <a:chOff x="0" y="0"/>
+          <a:chExt cx="0" cy="0"/>
+        </a:xfrm>
+      </p:grpSpPr>
+      <p:sp>
+        <p:nvSpPr>
+          <p:cNvPr id="2" name="Text 0"/>
+          <p:cNvSpPr txBox="1"/>
+          <p:nvPr/>
+        </p:nvSpPr>
+        <p:spPr>
+          <a:xfrm>
+            <a:off x="609600" y="361950"/>
+            <a:ext cx="10953750" cy="914400"/>
+          </a:xfrm>
+          <a:prstGeom prst="rect">
+            <a:avLst/>
+          </a:prstGeom>
+          <a:noFill/>
+          <a:ln/>
+        </p:spPr>
+        <p:txBody>
+          <a:bodyPr wrap="square" lIns="0" tIns="0" rIns="0" bIns="0" rtlCol="0" anchor="ctr"/>
+          <a:lstStyle/>
+          <a:p>
+            <a:pPr indent="0" marL="0">
+              <a:buNone/>
+            </a:pPr>
+            <a:r>
+              <a:rPr lang="en-US" sz="3600" b="1" dirty="0">
+                <a:solidFill>
+                  <a:srgbClr val="191919"/>
+                </a:solidFill>
+                <a:latin typeface="Arial Black" pitchFamily="34" charset="0"/>
+                <a:ea typeface="Arial Black" pitchFamily="34" charset="-122"/>
+                <a:cs typeface="Arial Black" pitchFamily="34" charset="-120"/>
+              </a:rPr>
+              <a:t>Exit ticket: programming vs. networking</a:t>
+            </a:r>
+            <a:endParaRPr lang="en-US" sz="3600" dirty="0"/>
+          </a:p>
+        </p:txBody>
+      </p:sp>
+      <p:sp>
+        <p:nvSpPr>
+          <p:cNvPr id="3" name="Text 1"/>
+          <p:cNvSpPr txBox="1"/>
+          <p:nvPr/>
+        </p:nvSpPr>
+        <p:spPr>
+          <a:xfrm>
+            <a:off x="628650" y="1295400"/>
+            <a:ext cx="10915650" cy="476250"/>
+          </a:xfrm>
+          <a:prstGeom prst="rect">
+            <a:avLst/>
+          </a:prstGeom>
+          <a:noFill/>
+          <a:ln/>
+        </p:spPr>
+        <p:txBody>
+          <a:bodyPr wrap="square" lIns="0" tIns="0" rIns="0" bIns="0" rtlCol="0" anchor="ctr"/>
+          <a:lstStyle/>
+          <a:p>
+            <a:pPr indent="0" marL="0">
+              <a:buNone/>
+            </a:pPr>
+            <a:r>
+              <a:rPr lang="en-US" sz="2100" dirty="0">
+                <a:solidFill>
+                  <a:srgbClr val="191919"/>
+                </a:solidFill>
+                <a:latin typeface="Arial" pitchFamily="34" charset="0"/>
+                <a:ea typeface="Arial" pitchFamily="34" charset="-122"/>
+                <a:cs typeface="Arial" pitchFamily="34" charset="-120"/>
+              </a:rPr>
+              <a:t>Open the Day 1 exit ticket on the Canvas page · 8 minutes</a:t>
+            </a:r>
+            <a:endParaRPr lang="en-US" sz="2100" dirty="0"/>
+          </a:p>
+        </p:txBody>
+      </p:sp>
+      <p:sp>
+        <p:nvSpPr>
+          <p:cNvPr id="4" name="Shape 2"/>
+          <p:cNvSpPr/>
+          <p:nvPr/>
+        </p:nvSpPr>
+        <p:spPr>
+          <a:xfrm>
+            <a:off x="609600" y="1905000"/>
+            <a:ext cx="6858000" cy="3143250"/>
+          </a:xfrm>
+          <a:prstGeom prst="rect">
+            <a:avLst/>
+          </a:prstGeom>
+          <a:solidFill>
+            <a:srgbClr val="FFFFFF"/>
+          </a:solidFill>
+          <a:ln w="12700">
+            <a:solidFill>
+              <a:srgbClr val="FFFFFF"/>
+            </a:solidFill>
+            <a:prstDash val="solid"/>
+          </a:ln>
+        </p:spPr>
+      </p:sp>
+      <p:sp>
+        <p:nvSpPr>
+          <p:cNvPr id="5" name="Text 3"/>
+          <p:cNvSpPr txBox="1"/>
+          <p:nvPr/>
+        </p:nvSpPr>
+        <p:spPr>
+          <a:xfrm>
+            <a:off x="838200" y="2057400"/>
+            <a:ext cx="6477000" cy="857250"/>
+          </a:xfrm>
+          <a:prstGeom prst="rect">
+            <a:avLst/>
+          </a:prstGeom>
+          <a:noFill/>
+          <a:ln/>
+        </p:spPr>
+        <p:txBody>
+          <a:bodyPr wrap="square" lIns="0" tIns="0" rIns="0" bIns="0" rtlCol="0" anchor="t"/>
+          <a:lstStyle/>
+          <a:p>
+            <a:pPr indent="0" marL="0">
+              <a:buNone/>
+            </a:pPr>
+            <a:r>
+              <a:rPr lang="en-US" sz="1900" dirty="0">
+                <a:solidFill>
+                  <a:srgbClr val="191919"/>
+                </a:solidFill>
+                <a:latin typeface="Arial" pitchFamily="34" charset="0"/>
+                <a:ea typeface="Arial" pitchFamily="34" charset="-122"/>
+                <a:cs typeface="Arial" pitchFamily="34" charset="-120"/>
+              </a:rPr>
+              <a:t>Pick one programming career from Week 2 (Software Dev, Web Dev, App Dev, or Game Dev).</a:t>
+            </a:r>
+            <a:endParaRPr lang="en-US" sz="1900" dirty="0"/>
+          </a:p>
+          <a:p>
+            <a:pPr indent="0" marL="0">
+              <a:buNone/>
+            </a:pPr>
+            <a:r>
+              <a:rPr lang="en-US" sz="1900" dirty="0">
+                <a:solidFill>
+                  <a:srgbClr val="191919"/>
+                </a:solidFill>
+                <a:latin typeface="Arial" pitchFamily="34" charset="0"/>
+                <a:ea typeface="Arial" pitchFamily="34" charset="-122"/>
+                <a:cs typeface="Arial" pitchFamily="34" charset="-120"/>
+              </a:rPr>
+              <a:t>Pick one networking career from today.</a:t>
+            </a:r>
+            <a:endParaRPr lang="en-US" sz="1900" dirty="0"/>
+          </a:p>
+        </p:txBody>
+      </p:sp>
+      <p:sp>
+        <p:nvSpPr>
+          <p:cNvPr id="6" name="Text 4"/>
+          <p:cNvSpPr txBox="1"/>
+          <p:nvPr/>
+        </p:nvSpPr>
+        <p:spPr>
+          <a:xfrm>
+            <a:off x="838200" y="3009900"/>
+            <a:ext cx="6477000" cy="1905000"/>
+          </a:xfrm>
+          <a:prstGeom prst="rect">
+            <a:avLst/>
+          </a:prstGeom>
+          <a:noFill/>
+          <a:ln/>
+        </p:spPr>
+        <p:txBody>
+          <a:bodyPr wrap="square" lIns="0" tIns="0" rIns="0" bIns="0" rtlCol="0" anchor="t"/>
+          <a:lstStyle/>
+          <a:p>
+            <a:pPr indent="0" marL="0">
+              <a:buNone/>
+            </a:pPr>
+            <a:r>
+              <a:rPr lang="en-US" sz="1800" dirty="0">
+                <a:solidFill>
+                  <a:srgbClr val="191919"/>
+                </a:solidFill>
+                <a:latin typeface="Arial" pitchFamily="34" charset="0"/>
+                <a:ea typeface="Arial" pitchFamily="34" charset="-122"/>
+                <a:cs typeface="Arial" pitchFamily="34" charset="-120"/>
+              </a:rPr>
+              <a:t>Left: 2 skills only the programmer uses.</a:t>
+            </a:r>
+            <a:endParaRPr lang="en-US" sz="1800" dirty="0"/>
+          </a:p>
+          <a:p>
+            <a:pPr indent="0" marL="0">
+              <a:buNone/>
+            </a:pPr>
+            <a:r>
+              <a:rPr lang="en-US" sz="1800" dirty="0">
+                <a:solidFill>
+                  <a:srgbClr val="191919"/>
+                </a:solidFill>
+                <a:latin typeface="Arial" pitchFamily="34" charset="0"/>
+                <a:ea typeface="Arial" pitchFamily="34" charset="-122"/>
+                <a:cs typeface="Arial" pitchFamily="34" charset="-120"/>
+              </a:rPr>
+              <a:t>Right: 2 skills only the networking career uses.</a:t>
+            </a:r>
+            <a:endParaRPr lang="en-US" sz="1800" dirty="0"/>
+          </a:p>
+          <a:p>
+            <a:pPr indent="0" marL="0">
+              <a:buNone/>
+            </a:pPr>
+            <a:r>
+              <a:rPr lang="en-US" sz="1800" dirty="0">
+                <a:solidFill>
+                  <a:srgbClr val="191919"/>
+                </a:solidFill>
+                <a:latin typeface="Arial" pitchFamily="34" charset="0"/>
+                <a:ea typeface="Arial" pitchFamily="34" charset="-122"/>
+                <a:cs typeface="Arial" pitchFamily="34" charset="-120"/>
+              </a:rPr>
+              <a:t>Middle: 2 skills BOTH need (soft skills, not technical).</a:t>
+            </a:r>
+            <a:endParaRPr lang="en-US" sz="1800" dirty="0"/>
+          </a:p>
+          <a:p>
+            <a:pPr indent="0" marL="0">
+              <a:buNone/>
+            </a:pPr>
+            <a:r>
+              <a:rPr lang="en-US" sz="1800" dirty="0">
+                <a:solidFill>
+                  <a:srgbClr val="191919"/>
+                </a:solidFill>
+                <a:latin typeface="Arial" pitchFamily="34" charset="0"/>
+                <a:ea typeface="Arial" pitchFamily="34" charset="-122"/>
+                <a:cs typeface="Arial" pitchFamily="34" charset="-120"/>
+              </a:rPr>
+              <a:t>Bottom line: why do employers care about the middle as much as the technical sides? One sentence.</a:t>
+            </a:r>
+            <a:endParaRPr lang="en-US" sz="1800" dirty="0"/>
+          </a:p>
+        </p:txBody>
+      </p:sp>
+      <p:pic>
+        <p:nvPicPr>
+          <p:cNvPr id="7" name="Image 0" descr="/home/claude/cce/build/slides/1sw-wk3/assets/cv-d1-exit.png">    </p:cNvPr>
+          <p:cNvPicPr>
+            <a:picLocks noChangeAspect="1"/>
+          </p:cNvPicPr>
+          <p:nvPr/>
+        </p:nvPicPr>
+        <p:blipFill>
+          <a:blip r:embed="rId1"/>
+          <a:stretch>
+            <a:fillRect/>
+          </a:stretch>
+        </p:blipFill>
+        <p:spPr>
+          <a:xfrm>
+            <a:off x="7810500" y="1905000"/>
+            <a:ext cx="3771900" cy="1333500"/>
+          </a:xfrm>
+          <a:prstGeom prst="rect">
+            <a:avLst/>
+          </a:prstGeom>
+        </p:spPr>
+      </p:pic>
+      <p:sp>
+        <p:nvSpPr>
+          <p:cNvPr id="8" name="Text 5"/>
+          <p:cNvSpPr txBox="1"/>
+          <p:nvPr/>
+        </p:nvSpPr>
+        <p:spPr>
+          <a:xfrm>
+            <a:off x="7810500" y="3333750"/>
+            <a:ext cx="3771900" cy="381000"/>
+          </a:xfrm>
+          <a:prstGeom prst="rect">
+            <a:avLst/>
+          </a:prstGeom>
+          <a:noFill/>
+          <a:ln/>
+        </p:spPr>
+        <p:txBody>
+          <a:bodyPr wrap="square" lIns="0" tIns="0" rIns="0" bIns="0" rtlCol="0" anchor="t"/>
+          <a:lstStyle/>
+          <a:p>
+            <a:pPr indent="0" marL="0">
+              <a:buNone/>
+            </a:pPr>
+            <a:r>
+              <a:rPr lang="en-US" sz="1500" dirty="0">
+                <a:solidFill>
+                  <a:srgbClr val="5F6368"/>
+                </a:solidFill>
+                <a:latin typeface="Arial" pitchFamily="34" charset="0"/>
+                <a:ea typeface="Arial" pitchFamily="34" charset="-122"/>
+                <a:cs typeface="Arial" pitchFamily="34" charset="-120"/>
+              </a:rPr>
+              <a:t>The button opens your own copy of the Venn diagram.</a:t>
+            </a:r>
+            <a:endParaRPr lang="en-US" sz="1500" dirty="0"/>
+          </a:p>
+        </p:txBody>
+      </p:sp>
+      <p:sp>
+        <p:nvSpPr>
+          <p:cNvPr id="9" name="Text 6"/>
+          <p:cNvSpPr txBox="1"/>
+          <p:nvPr/>
+        </p:nvSpPr>
+        <p:spPr>
+          <a:xfrm>
+            <a:off x="609600" y="5334000"/>
+            <a:ext cx="5715000" cy="400050"/>
+          </a:xfrm>
+          <a:prstGeom prst="rect">
+            <a:avLst/>
+          </a:prstGeom>
+          <a:noFill/>
+          <a:ln/>
+        </p:spPr>
+        <p:txBody>
+          <a:bodyPr wrap="square" lIns="0" tIns="0" rIns="0" bIns="0" rtlCol="0" anchor="ctr"/>
+          <a:lstStyle/>
+          <a:p>
+            <a:pPr indent="0" marL="0">
+              <a:buNone/>
+            </a:pPr>
+            <a:r>
+              <a:rPr lang="en-US" sz="2300" b="1" dirty="0">
+                <a:solidFill>
+                  <a:srgbClr val="1955DB"/>
+                </a:solidFill>
+                <a:latin typeface="Arial Black" pitchFamily="34" charset="0"/>
+                <a:ea typeface="Arial Black" pitchFamily="34" charset="-122"/>
+                <a:cs typeface="Arial Black" pitchFamily="34" charset="-120"/>
+              </a:rPr>
+              <a:t>Say it like this</a:t>
+            </a:r>
+            <a:endParaRPr lang="en-US" sz="2300" dirty="0"/>
+          </a:p>
+        </p:txBody>
+      </p:sp>
+      <p:sp>
+        <p:nvSpPr>
+          <p:cNvPr id="10" name="Text 7"/>
+          <p:cNvSpPr txBox="1"/>
+          <p:nvPr/>
+        </p:nvSpPr>
+        <p:spPr>
+          <a:xfrm>
+            <a:off x="609600" y="5772150"/>
+            <a:ext cx="10953750" cy="571500"/>
+          </a:xfrm>
+          <a:prstGeom prst="rect">
+            <a:avLst/>
+          </a:prstGeom>
+          <a:noFill/>
+          <a:ln/>
+        </p:spPr>
+        <p:txBody>
+          <a:bodyPr wrap="square" lIns="0" tIns="0" rIns="0" bIns="0" rtlCol="0" anchor="t"/>
+          <a:lstStyle/>
+          <a:p>
+            <a:pPr indent="0" marL="0">
+              <a:buNone/>
+            </a:pPr>
+            <a:r>
+              <a:rPr lang="en-US" sz="2400" dirty="0">
+                <a:solidFill>
+                  <a:srgbClr val="191919"/>
+                </a:solidFill>
+                <a:latin typeface="Arial" pitchFamily="34" charset="0"/>
+                <a:ea typeface="Arial" pitchFamily="34" charset="-122"/>
+                <a:cs typeface="Arial" pitchFamily="34" charset="-120"/>
+              </a:rPr>
+              <a:t>Employers care about ________ because ________.</a:t>
+            </a:r>
+            <a:endParaRPr lang="en-US" sz="2400" dirty="0"/>
+          </a:p>
+        </p:txBody>
+      </p:sp>
+    </p:spTree>
+  </p:cSld>
+  <p:clrMapOvr>
+    <a:masterClrMapping/>
+  </p:clrMapOvr>
+</p:sld>
+</file>
+
+<file path=ppt/slides/slide11.xml><?xml version="1.0" encoding="utf-8"?>
+<p:sld xmlns:a="http://schemas.openxmlformats.org/drawingml/2006/main" xmlns:r="http://schemas.openxmlformats.org/officeDocument/2006/relationships" xmlns:p="http://schemas.openxmlformats.org/presentationml/2006/main">
+  <p:cSld name="Slide 11">
+    <p:bg>
+      <p:bgPr>
+        <a:solidFill>
+          <a:srgbClr val="FAF7EF"/>
+        </a:solidFill>
+      </p:bgPr>
+    </p:bg>
+    <p:spTree>
+      <p:nvGrpSpPr>
+        <p:cNvPr id="1" name=""/>
+        <p:cNvGrpSpPr/>
+        <p:nvPr/>
+      </p:nvGrpSpPr>
+      <p:grpSpPr>
+        <a:xfrm>
+          <a:off x="0" y="0"/>
+          <a:ext cx="0" cy="0"/>
+          <a:chOff x="0" y="0"/>
+          <a:chExt cx="0" cy="0"/>
+        </a:xfrm>
+      </p:grpSpPr>
+      <p:sp>
+        <p:nvSpPr>
+          <p:cNvPr id="2" name="Text 0"/>
+          <p:cNvSpPr txBox="1"/>
+          <p:nvPr/>
+        </p:nvSpPr>
+        <p:spPr>
+          <a:xfrm>
+            <a:off x="609600" y="361950"/>
+            <a:ext cx="10953750" cy="914400"/>
+          </a:xfrm>
+          <a:prstGeom prst="rect">
+            <a:avLst/>
+          </a:prstGeom>
+          <a:noFill/>
+          <a:ln/>
+        </p:spPr>
+        <p:txBody>
+          <a:bodyPr wrap="square" lIns="0" tIns="0" rIns="0" bIns="0" rtlCol="0" anchor="ctr"/>
+          <a:lstStyle/>
+          <a:p>
+            <a:pPr indent="0" marL="0">
+              <a:buNone/>
+            </a:pPr>
+            <a:r>
+              <a:rPr lang="en-US" sz="4200" b="1" dirty="0">
+                <a:solidFill>
+                  <a:srgbClr val="191919"/>
+                </a:solidFill>
+                <a:latin typeface="Arial Black" pitchFamily="34" charset="0"/>
+                <a:ea typeface="Arial Black" pitchFamily="34" charset="-122"/>
+                <a:cs typeface="Arial Black" pitchFamily="34" charset="-120"/>
+              </a:rPr>
+              <a:t>Before you go</a:t>
+            </a:r>
+            <a:endParaRPr lang="en-US" sz="4200" dirty="0"/>
+          </a:p>
+        </p:txBody>
+      </p:sp>
+      <p:sp>
+        <p:nvSpPr>
+          <p:cNvPr id="3" name="Shape 1"/>
+          <p:cNvSpPr/>
+          <p:nvPr/>
+        </p:nvSpPr>
+        <p:spPr>
+          <a:xfrm>
+            <a:off x="609600" y="1952625"/>
+            <a:ext cx="10972800" cy="819150"/>
+          </a:xfrm>
+          <a:prstGeom prst="rect">
+            <a:avLst/>
+          </a:prstGeom>
+          <a:solidFill>
+            <a:srgbClr val="FFFFFF"/>
+          </a:solidFill>
+          <a:ln w="12700">
+            <a:solidFill>
+              <a:srgbClr val="FFFFFF"/>
+            </a:solidFill>
+            <a:prstDash val="solid"/>
+          </a:ln>
+        </p:spPr>
+      </p:sp>
+      <p:sp>
+        <p:nvSpPr>
+          <p:cNvPr id="4" name="Shape 2"/>
+          <p:cNvSpPr/>
+          <p:nvPr/>
+        </p:nvSpPr>
+        <p:spPr>
+          <a:xfrm>
+            <a:off x="800100" y="2105025"/>
+            <a:ext cx="457200" cy="457200"/>
+          </a:xfrm>
+          <a:prstGeom prst="ellipse">
+            <a:avLst/>
+          </a:prstGeom>
+          <a:solidFill>
+            <a:srgbClr val="1955DB"/>
+          </a:solidFill>
+          <a:ln w="12700">
+            <a:solidFill>
+              <a:srgbClr val="1955DB"/>
+            </a:solidFill>
+            <a:prstDash val="solid"/>
+          </a:ln>
+        </p:spPr>
+      </p:sp>
+      <p:sp>
+        <p:nvSpPr>
+          <p:cNvPr id="5" name="Text 3"/>
+          <p:cNvSpPr txBox="1"/>
+          <p:nvPr/>
+        </p:nvSpPr>
+        <p:spPr>
+          <a:xfrm>
+            <a:off x="800100" y="2105025"/>
+            <a:ext cx="457200" cy="457200"/>
+          </a:xfrm>
+          <a:prstGeom prst="rect">
+            <a:avLst/>
+          </a:prstGeom>
+          <a:noFill/>
+          <a:ln/>
+        </p:spPr>
+        <p:txBody>
+          <a:bodyPr wrap="square" lIns="0" tIns="0" rIns="0" bIns="0" rtlCol="0" anchor="ctr"/>
+          <a:lstStyle/>
+          <a:p>
+            <a:pPr algn="ctr" indent="0" marL="0">
+              <a:buNone/>
+            </a:pPr>
+            <a:r>
+              <a:rPr lang="en-US" sz="2000" b="1" dirty="0">
+                <a:solidFill>
+                  <a:srgbClr val="FFFFFF"/>
+                </a:solidFill>
+                <a:latin typeface="Arial Black" pitchFamily="34" charset="0"/>
+                <a:ea typeface="Arial Black" pitchFamily="34" charset="-122"/>
+                <a:cs typeface="Arial Black" pitchFamily="34" charset="-120"/>
+              </a:rPr>
+              <a:t>1</a:t>
+            </a:r>
+            <a:endParaRPr lang="en-US" sz="2000" dirty="0"/>
+          </a:p>
+        </p:txBody>
+      </p:sp>
+      <p:sp>
+        <p:nvSpPr>
+          <p:cNvPr id="6" name="Text 4"/>
+          <p:cNvSpPr txBox="1"/>
+          <p:nvPr/>
+        </p:nvSpPr>
+        <p:spPr>
+          <a:xfrm>
+            <a:off x="1447800" y="2066925"/>
+            <a:ext cx="9925050" cy="628650"/>
+          </a:xfrm>
+          <a:prstGeom prst="rect">
+            <a:avLst/>
+          </a:prstGeom>
+          <a:noFill/>
+          <a:ln/>
+        </p:spPr>
+        <p:txBody>
+          <a:bodyPr wrap="square" lIns="0" tIns="0" rIns="0" bIns="0" rtlCol="0" anchor="ctr"/>
+          <a:lstStyle/>
+          <a:p>
+            <a:pPr indent="0" marL="0">
+              <a:buNone/>
+            </a:pPr>
+            <a:r>
+              <a:rPr lang="en-US" sz="2400" dirty="0">
+                <a:solidFill>
+                  <a:srgbClr val="191919"/>
+                </a:solidFill>
+                <a:latin typeface="Arial" pitchFamily="34" charset="0"/>
+                <a:ea typeface="Arial" pitchFamily="34" charset="-122"/>
+                <a:cs typeface="Arial" pitchFamily="34" charset="-120"/>
+              </a:rPr>
+              <a:t>Four rows done: a task and a skill for each career.</a:t>
+            </a:r>
+            <a:endParaRPr lang="en-US" sz="2400" dirty="0"/>
+          </a:p>
+        </p:txBody>
+      </p:sp>
+      <p:sp>
+        <p:nvSpPr>
+          <p:cNvPr id="7" name="Shape 5"/>
+          <p:cNvSpPr/>
+          <p:nvPr/>
+        </p:nvSpPr>
+        <p:spPr>
+          <a:xfrm>
+            <a:off x="609600" y="2905125"/>
+            <a:ext cx="10972800" cy="819150"/>
+          </a:xfrm>
+          <a:prstGeom prst="rect">
+            <a:avLst/>
+          </a:prstGeom>
+          <a:solidFill>
+            <a:srgbClr val="FFFFFF"/>
+          </a:solidFill>
+          <a:ln w="12700">
+            <a:solidFill>
+              <a:srgbClr val="FFFFFF"/>
+            </a:solidFill>
+            <a:prstDash val="solid"/>
+          </a:ln>
+        </p:spPr>
+      </p:sp>
+      <p:sp>
+        <p:nvSpPr>
+          <p:cNvPr id="8" name="Shape 6"/>
+          <p:cNvSpPr/>
+          <p:nvPr/>
+        </p:nvSpPr>
+        <p:spPr>
+          <a:xfrm>
+            <a:off x="800100" y="3057525"/>
+            <a:ext cx="457200" cy="457200"/>
+          </a:xfrm>
+          <a:prstGeom prst="ellipse">
+            <a:avLst/>
+          </a:prstGeom>
+          <a:solidFill>
+            <a:srgbClr val="1955DB"/>
+          </a:solidFill>
+          <a:ln w="12700">
+            <a:solidFill>
+              <a:srgbClr val="1955DB"/>
+            </a:solidFill>
+            <a:prstDash val="solid"/>
+          </a:ln>
+        </p:spPr>
+      </p:sp>
+      <p:sp>
+        <p:nvSpPr>
+          <p:cNvPr id="9" name="Text 7"/>
+          <p:cNvSpPr txBox="1"/>
+          <p:nvPr/>
+        </p:nvSpPr>
+        <p:spPr>
+          <a:xfrm>
+            <a:off x="800100" y="3057525"/>
+            <a:ext cx="457200" cy="457200"/>
+          </a:xfrm>
+          <a:prstGeom prst="rect">
+            <a:avLst/>
+          </a:prstGeom>
+          <a:noFill/>
+          <a:ln/>
+        </p:spPr>
+        <p:txBody>
+          <a:bodyPr wrap="square" lIns="0" tIns="0" rIns="0" bIns="0" rtlCol="0" anchor="ctr"/>
+          <a:lstStyle/>
+          <a:p>
+            <a:pPr algn="ctr" indent="0" marL="0">
+              <a:buNone/>
+            </a:pPr>
+            <a:r>
+              <a:rPr lang="en-US" sz="2000" b="1" dirty="0">
+                <a:solidFill>
+                  <a:srgbClr val="FFFFFF"/>
+                </a:solidFill>
+                <a:latin typeface="Arial Black" pitchFamily="34" charset="0"/>
+                <a:ea typeface="Arial Black" pitchFamily="34" charset="-122"/>
+                <a:cs typeface="Arial Black" pitchFamily="34" charset="-120"/>
+              </a:rPr>
+              <a:t>2</a:t>
+            </a:r>
+            <a:endParaRPr lang="en-US" sz="2000" dirty="0"/>
+          </a:p>
+        </p:txBody>
+      </p:sp>
+      <p:sp>
+        <p:nvSpPr>
+          <p:cNvPr id="10" name="Text 8"/>
+          <p:cNvSpPr txBox="1"/>
+          <p:nvPr/>
+        </p:nvSpPr>
+        <p:spPr>
+          <a:xfrm>
+            <a:off x="1447800" y="3019425"/>
+            <a:ext cx="9925050" cy="628650"/>
+          </a:xfrm>
+          <a:prstGeom prst="rect">
+            <a:avLst/>
+          </a:prstGeom>
+          <a:noFill/>
+          <a:ln/>
+        </p:spPr>
+        <p:txBody>
+          <a:bodyPr wrap="square" lIns="0" tIns="0" rIns="0" bIns="0" rtlCol="0" anchor="ctr"/>
+          <a:lstStyle/>
+          <a:p>
+            <a:pPr indent="0" marL="0">
+              <a:buNone/>
+            </a:pPr>
+            <a:r>
+              <a:rPr lang="en-US" sz="2400" dirty="0">
+                <a:solidFill>
+                  <a:srgbClr val="191919"/>
+                </a:solidFill>
+                <a:latin typeface="Arial" pitchFamily="34" charset="0"/>
+                <a:ea typeface="Arial" pitchFamily="34" charset="-122"/>
+                <a:cs typeface="Arial" pitchFamily="34" charset="-120"/>
+              </a:rPr>
+              <a:t>Your Stop and Jot sentence in your notebook.</a:t>
+            </a:r>
+            <a:endParaRPr lang="en-US" sz="2400" dirty="0"/>
+          </a:p>
+        </p:txBody>
+      </p:sp>
+      <p:sp>
+        <p:nvSpPr>
+          <p:cNvPr id="11" name="Shape 9"/>
+          <p:cNvSpPr/>
+          <p:nvPr/>
+        </p:nvSpPr>
+        <p:spPr>
+          <a:xfrm>
+            <a:off x="609600" y="3857625"/>
+            <a:ext cx="10972800" cy="819150"/>
+          </a:xfrm>
+          <a:prstGeom prst="rect">
+            <a:avLst/>
+          </a:prstGeom>
+          <a:solidFill>
+            <a:srgbClr val="FFFFFF"/>
+          </a:solidFill>
+          <a:ln w="12700">
+            <a:solidFill>
+              <a:srgbClr val="FFFFFF"/>
+            </a:solidFill>
+            <a:prstDash val="solid"/>
+          </a:ln>
+        </p:spPr>
+      </p:sp>
+      <p:sp>
+        <p:nvSpPr>
+          <p:cNvPr id="12" name="Shape 10"/>
+          <p:cNvSpPr/>
+          <p:nvPr/>
+        </p:nvSpPr>
+        <p:spPr>
+          <a:xfrm>
+            <a:off x="800100" y="4010025"/>
+            <a:ext cx="457200" cy="457200"/>
+          </a:xfrm>
+          <a:prstGeom prst="ellipse">
+            <a:avLst/>
+          </a:prstGeom>
+          <a:solidFill>
+            <a:srgbClr val="1955DB"/>
+          </a:solidFill>
+          <a:ln w="12700">
+            <a:solidFill>
+              <a:srgbClr val="1955DB"/>
+            </a:solidFill>
+            <a:prstDash val="solid"/>
+          </a:ln>
+        </p:spPr>
+      </p:sp>
+      <p:sp>
+        <p:nvSpPr>
+          <p:cNvPr id="13" name="Text 11"/>
+          <p:cNvSpPr txBox="1"/>
+          <p:nvPr/>
+        </p:nvSpPr>
+        <p:spPr>
+          <a:xfrm>
+            <a:off x="800100" y="4010025"/>
+            <a:ext cx="457200" cy="457200"/>
+          </a:xfrm>
+          <a:prstGeom prst="rect">
+            <a:avLst/>
+          </a:prstGeom>
+          <a:noFill/>
+          <a:ln/>
+        </p:spPr>
+        <p:txBody>
+          <a:bodyPr wrap="square" lIns="0" tIns="0" rIns="0" bIns="0" rtlCol="0" anchor="ctr"/>
+          <a:lstStyle/>
+          <a:p>
+            <a:pPr algn="ctr" indent="0" marL="0">
+              <a:buNone/>
+            </a:pPr>
+            <a:r>
+              <a:rPr lang="en-US" sz="2000" b="1" dirty="0">
+                <a:solidFill>
+                  <a:srgbClr val="FFFFFF"/>
+                </a:solidFill>
+                <a:latin typeface="Arial Black" pitchFamily="34" charset="0"/>
+                <a:ea typeface="Arial Black" pitchFamily="34" charset="-122"/>
+                <a:cs typeface="Arial Black" pitchFamily="34" charset="-120"/>
+              </a:rPr>
+              <a:t>3</a:t>
+            </a:r>
+            <a:endParaRPr lang="en-US" sz="2000" dirty="0"/>
+          </a:p>
+        </p:txBody>
+      </p:sp>
+      <p:sp>
+        <p:nvSpPr>
+          <p:cNvPr id="14" name="Text 12"/>
+          <p:cNvSpPr txBox="1"/>
+          <p:nvPr/>
+        </p:nvSpPr>
+        <p:spPr>
+          <a:xfrm>
+            <a:off x="1447800" y="3971925"/>
+            <a:ext cx="9925050" cy="628650"/>
+          </a:xfrm>
+          <a:prstGeom prst="rect">
+            <a:avLst/>
+          </a:prstGeom>
+          <a:noFill/>
+          <a:ln/>
+        </p:spPr>
+        <p:txBody>
+          <a:bodyPr wrap="square" lIns="0" tIns="0" rIns="0" bIns="0" rtlCol="0" anchor="ctr"/>
+          <a:lstStyle/>
+          <a:p>
+            <a:pPr indent="0" marL="0">
+              <a:buNone/>
+            </a:pPr>
+            <a:r>
+              <a:rPr lang="en-US" sz="2400" dirty="0">
+                <a:solidFill>
+                  <a:srgbClr val="191919"/>
+                </a:solidFill>
+                <a:latin typeface="Arial" pitchFamily="34" charset="0"/>
+                <a:ea typeface="Arial" pitchFamily="34" charset="-122"/>
+                <a:cs typeface="Arial" pitchFamily="34" charset="-120"/>
+              </a:rPr>
+              <a:t>Exit ticket submitted.</a:t>
+            </a:r>
+            <a:endParaRPr lang="en-US" sz="2400" dirty="0"/>
+          </a:p>
+        </p:txBody>
+      </p:sp>
+      <p:sp>
+        <p:nvSpPr>
+          <p:cNvPr id="15" name="Text 13"/>
+          <p:cNvSpPr txBox="1"/>
+          <p:nvPr/>
+        </p:nvSpPr>
+        <p:spPr>
+          <a:xfrm>
+            <a:off x="609600" y="5143500"/>
+            <a:ext cx="10953750" cy="571500"/>
+          </a:xfrm>
+          <a:prstGeom prst="rect">
+            <a:avLst/>
+          </a:prstGeom>
+          <a:noFill/>
+          <a:ln/>
+        </p:spPr>
+        <p:txBody>
+          <a:bodyPr wrap="square" lIns="0" tIns="0" rIns="0" bIns="0" rtlCol="0" anchor="t"/>
+          <a:lstStyle/>
+          <a:p>
+            <a:pPr indent="0" marL="0">
+              <a:buNone/>
+            </a:pPr>
+            <a:r>
+              <a:rPr lang="en-US" sz="2200" b="1" dirty="0">
+                <a:solidFill>
+                  <a:srgbClr val="191919"/>
+                </a:solidFill>
+                <a:latin typeface="Arial" pitchFamily="34" charset="0"/>
+                <a:ea typeface="Arial" pitchFamily="34" charset="-122"/>
+                <a:cs typeface="Arial" pitchFamily="34" charset="-120"/>
+              </a:rPr>
+              <a:t>Tomorrow: you become a UX designer and audit a real website. Bring your Find Your Future workbook.</a:t>
+            </a:r>
+            <a:endParaRPr lang="en-US" sz="2200" dirty="0"/>
           </a:p>
         </p:txBody>
       </p:sp>
@@ -2223,7 +3321,7 @@
                 <a:ea typeface="Arial" pitchFamily="34" charset="-122"/>
                 <a:cs typeface="Arial" pitchFamily="34" charset="-120"/>
               </a:rPr>
-              <a:t>Compare four careers that keep systems running: Network Administrator, Network Architect, Database Administrator, Systems Analyst.</a:t>
+              <a:t>Learn what a network is and meet the four careers that keep one running.</a:t>
             </a:r>
             <a:endParaRPr lang="en-US" sz="2200" dirty="0"/>
           </a:p>
@@ -2717,61 +3815,85 @@
                 <a:ea typeface="Arial Black" pitchFamily="34" charset="-122"/>
                 <a:cs typeface="Arial Black" pitchFamily="34" charset="-120"/>
               </a:rPr>
-              <a:t>Four careers, one network</a:t>
+              <a:t>What is a network?</a:t>
             </a:r>
             <a:endParaRPr lang="en-US" sz="4200" dirty="0"/>
           </a:p>
         </p:txBody>
       </p:sp>
-      <p:sp>
-        <p:nvSpPr>
-          <p:cNvPr id="3" name="Text 1"/>
-          <p:cNvSpPr txBox="1"/>
-          <p:nvPr/>
-        </p:nvSpPr>
-        <p:spPr>
-          <a:xfrm>
-            <a:off x="628650" y="1295400"/>
-            <a:ext cx="10915650" cy="476250"/>
-          </a:xfrm>
-          <a:prstGeom prst="rect">
-            <a:avLst/>
-          </a:prstGeom>
-          <a:noFill/>
-          <a:ln/>
-        </p:spPr>
-        <p:txBody>
-          <a:bodyPr wrap="square" lIns="0" tIns="0" rIns="0" bIns="0" rtlCol="0" anchor="ctr"/>
-          <a:lstStyle/>
-          <a:p>
-            <a:pPr indent="0" marL="0">
-              <a:buNone/>
-            </a:pPr>
-            <a:r>
-              <a:rPr lang="en-US" sz="2100" dirty="0">
-                <a:solidFill>
-                  <a:srgbClr val="191919"/>
-                </a:solidFill>
-                <a:latin typeface="Arial" pitchFamily="34" charset="0"/>
-                <a:ea typeface="Arial" pitchFamily="34" charset="-122"/>
-                <a:cs typeface="Arial" pitchFamily="34" charset="-120"/>
-              </a:rPr>
-              <a:t>Networking Career Cards · link on the Day 1 page</a:t>
-            </a:r>
-            <a:endParaRPr lang="en-US" sz="2100" dirty="0"/>
-          </a:p>
-        </p:txBody>
-      </p:sp>
-      <p:sp>
-        <p:nvSpPr>
-          <p:cNvPr id="4" name="Shape 2"/>
+      <p:pic>
+        <p:nvPicPr>
+          <p:cNvPr id="3" name="Image 0" descr="/home/claude/cce/build/slides/1sw-wk3/assets/bls-network-photo.jpg">    </p:cNvPr>
+          <p:cNvPicPr>
+            <a:picLocks noChangeAspect="1"/>
+          </p:cNvPicPr>
+          <p:nvPr/>
+        </p:nvPicPr>
+        <p:blipFill>
+          <a:blip r:embed="rId1"/>
+          <a:stretch>
+            <a:fillRect/>
+          </a:stretch>
+        </p:blipFill>
+        <p:spPr>
+          <a:xfrm>
+            <a:off x="609600" y="1905000"/>
+            <a:ext cx="4267200" cy="1266825"/>
+          </a:xfrm>
+          <a:prstGeom prst="rect">
+            <a:avLst/>
+          </a:prstGeom>
+        </p:spPr>
+      </p:pic>
+      <p:sp>
+        <p:nvSpPr>
+          <p:cNvPr id="4" name="Text 1"/>
+          <p:cNvSpPr txBox="1"/>
+          <p:nvPr/>
+        </p:nvSpPr>
+        <p:spPr>
+          <a:xfrm>
+            <a:off x="609600" y="3238500"/>
+            <a:ext cx="4267200" cy="381000"/>
+          </a:xfrm>
+          <a:prstGeom prst="rect">
+            <a:avLst/>
+          </a:prstGeom>
+          <a:noFill/>
+          <a:ln/>
+        </p:spPr>
+        <p:txBody>
+          <a:bodyPr wrap="square" lIns="0" tIns="0" rIns="0" bIns="0" rtlCol="0" anchor="t"/>
+          <a:lstStyle/>
+          <a:p>
+            <a:pPr indent="0" marL="0">
+              <a:buNone/>
+            </a:pPr>
+            <a:r>
+              <a:rPr lang="en-US" sz="1500" dirty="0">
+                <a:solidFill>
+                  <a:srgbClr val="5F6368"/>
+                </a:solidFill>
+                <a:latin typeface="Arial" pitchFamily="34" charset="0"/>
+                <a:ea typeface="Arial" pitchFamily="34" charset="-122"/>
+                <a:cs typeface="Arial" pitchFamily="34" charset="-120"/>
+              </a:rPr>
+              <a:t>Network cables in a server room (BLS video still)</a:t>
+            </a:r>
+            <a:endParaRPr lang="en-US" sz="1500" dirty="0"/>
+          </a:p>
+        </p:txBody>
+      </p:sp>
+      <p:sp>
+        <p:nvSpPr>
+          <p:cNvPr id="5" name="Shape 2"/>
           <p:cNvSpPr/>
           <p:nvPr/>
         </p:nvSpPr>
         <p:spPr>
           <a:xfrm>
-            <a:off x="609600" y="1905000"/>
-            <a:ext cx="5372100" cy="1295400"/>
+            <a:off x="5238750" y="1905000"/>
+            <a:ext cx="6343650" cy="3200400"/>
           </a:xfrm>
           <a:prstGeom prst="rect">
             <a:avLst/>
@@ -2789,14 +3911,14 @@
       </p:sp>
       <p:sp>
         <p:nvSpPr>
-          <p:cNvPr id="5" name="Text 3"/>
-          <p:cNvSpPr txBox="1"/>
-          <p:nvPr/>
-        </p:nvSpPr>
-        <p:spPr>
-          <a:xfrm>
-            <a:off x="800100" y="2019300"/>
-            <a:ext cx="5048250" cy="323850"/>
+          <p:cNvPr id="6" name="Text 3"/>
+          <p:cNvSpPr txBox="1"/>
+          <p:nvPr/>
+        </p:nvSpPr>
+        <p:spPr>
+          <a:xfrm>
+            <a:off x="5467350" y="2095500"/>
+            <a:ext cx="5905500" cy="952500"/>
           </a:xfrm>
           <a:prstGeom prst="rect">
             <a:avLst/>
@@ -2812,30 +3934,30 @@
               <a:buNone/>
             </a:pPr>
             <a:r>
-              <a:rPr lang="en-US" sz="2000" b="1" dirty="0">
-                <a:solidFill>
-                  <a:srgbClr val="1955DB"/>
-                </a:solidFill>
-                <a:latin typeface="Arial" pitchFamily="34" charset="0"/>
-                <a:ea typeface="Arial" pitchFamily="34" charset="-122"/>
-                <a:cs typeface="Arial" pitchFamily="34" charset="-120"/>
-              </a:rPr>
-              <a:t>Network Administrator</a:t>
-            </a:r>
-            <a:endParaRPr lang="en-US" sz="2000" dirty="0"/>
-          </a:p>
-        </p:txBody>
-      </p:sp>
-      <p:sp>
-        <p:nvSpPr>
-          <p:cNvPr id="6" name="Text 4"/>
-          <p:cNvSpPr txBox="1"/>
-          <p:nvPr/>
-        </p:nvSpPr>
-        <p:spPr>
-          <a:xfrm>
-            <a:off x="800100" y="2381250"/>
-            <a:ext cx="5048250" cy="762000"/>
+              <a:rPr lang="en-US" sz="2200" b="1" dirty="0">
+                <a:solidFill>
+                  <a:srgbClr val="191919"/>
+                </a:solidFill>
+                <a:latin typeface="Arial" pitchFamily="34" charset="0"/>
+                <a:ea typeface="Arial" pitchFamily="34" charset="-122"/>
+                <a:cs typeface="Arial" pitchFamily="34" charset="-120"/>
+              </a:rPr>
+              <a:t>A network is a group of connected computers and devices that share information and resources.</a:t>
+            </a:r>
+            <a:endParaRPr lang="en-US" sz="2200" dirty="0"/>
+          </a:p>
+        </p:txBody>
+      </p:sp>
+      <p:sp>
+        <p:nvSpPr>
+          <p:cNvPr id="7" name="Text 4"/>
+          <p:cNvSpPr txBox="1"/>
+          <p:nvPr/>
+        </p:nvSpPr>
+        <p:spPr>
+          <a:xfrm>
+            <a:off x="5467350" y="3143250"/>
+            <a:ext cx="5905500" cy="1809750"/>
           </a:xfrm>
           <a:prstGeom prst="rect">
             <a:avLst/>
@@ -2851,7 +3973,7 @@
               <a:buNone/>
             </a:pPr>
             <a:r>
-              <a:rPr lang="en-US" sz="1600" dirty="0">
+              <a:rPr lang="en-US" sz="1900" dirty="0">
                 <a:solidFill>
                   <a:srgbClr val="191919"/>
                 </a:solidFill>
@@ -2859,102 +3981,22 @@
                 <a:ea typeface="Arial" pitchFamily="34" charset="-122"/>
                 <a:cs typeface="Arial" pitchFamily="34" charset="-120"/>
               </a:rPr>
-              <a:t>Keeps the network running day to day: accounts, monitoring, troubleshooting, updates.</a:t>
-            </a:r>
-            <a:endParaRPr lang="en-US" sz="1600" dirty="0"/>
-          </a:p>
-        </p:txBody>
-      </p:sp>
-      <p:sp>
-        <p:nvSpPr>
-          <p:cNvPr id="7" name="Shape 5"/>
-          <p:cNvSpPr/>
-          <p:nvPr/>
-        </p:nvSpPr>
-        <p:spPr>
-          <a:xfrm>
-            <a:off x="6210300" y="1905000"/>
-            <a:ext cx="5372100" cy="1295400"/>
-          </a:xfrm>
-          <a:prstGeom prst="rect">
-            <a:avLst/>
-          </a:prstGeom>
-          <a:solidFill>
-            <a:srgbClr val="FFFFFF"/>
-          </a:solidFill>
-          <a:ln w="12700">
-            <a:solidFill>
-              <a:srgbClr val="FFFFFF"/>
-            </a:solidFill>
-            <a:prstDash val="solid"/>
-          </a:ln>
-        </p:spPr>
-      </p:sp>
-      <p:sp>
-        <p:nvSpPr>
-          <p:cNvPr id="8" name="Text 6"/>
-          <p:cNvSpPr txBox="1"/>
-          <p:nvPr/>
-        </p:nvSpPr>
-        <p:spPr>
-          <a:xfrm>
-            <a:off x="6400800" y="2019300"/>
-            <a:ext cx="5048250" cy="323850"/>
-          </a:xfrm>
-          <a:prstGeom prst="rect">
-            <a:avLst/>
-          </a:prstGeom>
-          <a:noFill/>
-          <a:ln/>
-        </p:spPr>
-        <p:txBody>
-          <a:bodyPr wrap="square" lIns="0" tIns="0" rIns="0" bIns="0" rtlCol="0" anchor="t"/>
-          <a:lstStyle/>
-          <a:p>
-            <a:pPr indent="0" marL="0">
-              <a:buNone/>
-            </a:pPr>
-            <a:r>
-              <a:rPr lang="en-US" sz="2000" b="1" dirty="0">
-                <a:solidFill>
-                  <a:srgbClr val="1955DB"/>
-                </a:solidFill>
-                <a:latin typeface="Arial" pitchFamily="34" charset="0"/>
-                <a:ea typeface="Arial" pitchFamily="34" charset="-122"/>
-                <a:cs typeface="Arial" pitchFamily="34" charset="-120"/>
-              </a:rPr>
-              <a:t>Network Architect</a:t>
-            </a:r>
-            <a:endParaRPr lang="en-US" sz="2000" dirty="0"/>
-          </a:p>
-        </p:txBody>
-      </p:sp>
-      <p:sp>
-        <p:nvSpPr>
-          <p:cNvPr id="9" name="Text 7"/>
-          <p:cNvSpPr txBox="1"/>
-          <p:nvPr/>
-        </p:nvSpPr>
-        <p:spPr>
-          <a:xfrm>
-            <a:off x="6400800" y="2381250"/>
-            <a:ext cx="5048250" cy="762000"/>
-          </a:xfrm>
-          <a:prstGeom prst="rect">
-            <a:avLst/>
-          </a:prstGeom>
-          <a:noFill/>
-          <a:ln/>
-        </p:spPr>
-        <p:txBody>
-          <a:bodyPr wrap="square" lIns="0" tIns="0" rIns="0" bIns="0" rtlCol="0" anchor="t"/>
-          <a:lstStyle/>
-          <a:p>
-            <a:pPr indent="0" marL="0">
-              <a:buNone/>
-            </a:pPr>
-            <a:r>
-              <a:rPr lang="en-US" sz="1600" dirty="0">
+              <a:t>Your school Wi-Fi is a network. So is the bank app on a phone, and a text message on its way to someone.</a:t>
+            </a:r>
+            <a:endParaRPr lang="en-US" sz="1900" dirty="0"/>
+          </a:p>
+          <a:p>
+            <a:pPr indent="0" marL="0">
+              <a:buNone/>
+            </a:pPr>
+            <a:endParaRPr lang="en-US" sz="1900" dirty="0"/>
+          </a:p>
+          <a:p>
+            <a:pPr indent="0" marL="0">
+              <a:buNone/>
+            </a:pPr>
+            <a:r>
+              <a:rPr lang="en-US" sz="1900" dirty="0">
                 <a:solidFill>
                   <a:srgbClr val="191919"/>
                 </a:solidFill>
@@ -2962,295 +4004,9 @@
                 <a:ea typeface="Arial" pitchFamily="34" charset="-122"/>
                 <a:cs typeface="Arial" pitchFamily="34" charset="-120"/>
               </a:rPr>
-              <a:t>Plans and designs the network: equipment, capacity, security, cost tradeoffs.</a:t>
-            </a:r>
-            <a:endParaRPr lang="en-US" sz="1600" dirty="0"/>
-          </a:p>
-        </p:txBody>
-      </p:sp>
-      <p:sp>
-        <p:nvSpPr>
-          <p:cNvPr id="10" name="Shape 8"/>
-          <p:cNvSpPr/>
-          <p:nvPr/>
-        </p:nvSpPr>
-        <p:spPr>
-          <a:xfrm>
-            <a:off x="609600" y="3333750"/>
-            <a:ext cx="5372100" cy="1295400"/>
-          </a:xfrm>
-          <a:prstGeom prst="rect">
-            <a:avLst/>
-          </a:prstGeom>
-          <a:solidFill>
-            <a:srgbClr val="FFFFFF"/>
-          </a:solidFill>
-          <a:ln w="12700">
-            <a:solidFill>
-              <a:srgbClr val="FFFFFF"/>
-            </a:solidFill>
-            <a:prstDash val="solid"/>
-          </a:ln>
-        </p:spPr>
-      </p:sp>
-      <p:sp>
-        <p:nvSpPr>
-          <p:cNvPr id="11" name="Text 9"/>
-          <p:cNvSpPr txBox="1"/>
-          <p:nvPr/>
-        </p:nvSpPr>
-        <p:spPr>
-          <a:xfrm>
-            <a:off x="800100" y="3448050"/>
-            <a:ext cx="5048250" cy="323850"/>
-          </a:xfrm>
-          <a:prstGeom prst="rect">
-            <a:avLst/>
-          </a:prstGeom>
-          <a:noFill/>
-          <a:ln/>
-        </p:spPr>
-        <p:txBody>
-          <a:bodyPr wrap="square" lIns="0" tIns="0" rIns="0" bIns="0" rtlCol="0" anchor="t"/>
-          <a:lstStyle/>
-          <a:p>
-            <a:pPr indent="0" marL="0">
-              <a:buNone/>
-            </a:pPr>
-            <a:r>
-              <a:rPr lang="en-US" sz="2000" b="1" dirty="0">
-                <a:solidFill>
-                  <a:srgbClr val="1955DB"/>
-                </a:solidFill>
-                <a:latin typeface="Arial" pitchFamily="34" charset="0"/>
-                <a:ea typeface="Arial" pitchFamily="34" charset="-122"/>
-                <a:cs typeface="Arial" pitchFamily="34" charset="-120"/>
-              </a:rPr>
-              <a:t>Database Administrator</a:t>
-            </a:r>
-            <a:endParaRPr lang="en-US" sz="2000" dirty="0"/>
-          </a:p>
-        </p:txBody>
-      </p:sp>
-      <p:sp>
-        <p:nvSpPr>
-          <p:cNvPr id="12" name="Text 10"/>
-          <p:cNvSpPr txBox="1"/>
-          <p:nvPr/>
-        </p:nvSpPr>
-        <p:spPr>
-          <a:xfrm>
-            <a:off x="800100" y="3810000"/>
-            <a:ext cx="5048250" cy="762000"/>
-          </a:xfrm>
-          <a:prstGeom prst="rect">
-            <a:avLst/>
-          </a:prstGeom>
-          <a:noFill/>
-          <a:ln/>
-        </p:spPr>
-        <p:txBody>
-          <a:bodyPr wrap="square" lIns="0" tIns="0" rIns="0" bIns="0" rtlCol="0" anchor="t"/>
-          <a:lstStyle/>
-          <a:p>
-            <a:pPr indent="0" marL="0">
-              <a:buNone/>
-            </a:pPr>
-            <a:r>
-              <a:rPr lang="en-US" sz="1600" dirty="0">
-                <a:solidFill>
-                  <a:srgbClr val="191919"/>
-                </a:solidFill>
-                <a:latin typeface="Arial" pitchFamily="34" charset="0"/>
-                <a:ea typeface="Arial" pitchFamily="34" charset="-122"/>
-                <a:cs typeface="Arial" pitchFamily="34" charset="-120"/>
-              </a:rPr>
-              <a:t>Organizes, protects, and backs up data so users get reliable answers.</a:t>
-            </a:r>
-            <a:endParaRPr lang="en-US" sz="1600" dirty="0"/>
-          </a:p>
-        </p:txBody>
-      </p:sp>
-      <p:sp>
-        <p:nvSpPr>
-          <p:cNvPr id="13" name="Shape 11"/>
-          <p:cNvSpPr/>
-          <p:nvPr/>
-        </p:nvSpPr>
-        <p:spPr>
-          <a:xfrm>
-            <a:off x="6210300" y="3333750"/>
-            <a:ext cx="5372100" cy="1295400"/>
-          </a:xfrm>
-          <a:prstGeom prst="rect">
-            <a:avLst/>
-          </a:prstGeom>
-          <a:solidFill>
-            <a:srgbClr val="FFFFFF"/>
-          </a:solidFill>
-          <a:ln w="12700">
-            <a:solidFill>
-              <a:srgbClr val="FFFFFF"/>
-            </a:solidFill>
-            <a:prstDash val="solid"/>
-          </a:ln>
-        </p:spPr>
-      </p:sp>
-      <p:sp>
-        <p:nvSpPr>
-          <p:cNvPr id="14" name="Text 12"/>
-          <p:cNvSpPr txBox="1"/>
-          <p:nvPr/>
-        </p:nvSpPr>
-        <p:spPr>
-          <a:xfrm>
-            <a:off x="6400800" y="3448050"/>
-            <a:ext cx="5048250" cy="323850"/>
-          </a:xfrm>
-          <a:prstGeom prst="rect">
-            <a:avLst/>
-          </a:prstGeom>
-          <a:noFill/>
-          <a:ln/>
-        </p:spPr>
-        <p:txBody>
-          <a:bodyPr wrap="square" lIns="0" tIns="0" rIns="0" bIns="0" rtlCol="0" anchor="t"/>
-          <a:lstStyle/>
-          <a:p>
-            <a:pPr indent="0" marL="0">
-              <a:buNone/>
-            </a:pPr>
-            <a:r>
-              <a:rPr lang="en-US" sz="2000" b="1" dirty="0">
-                <a:solidFill>
-                  <a:srgbClr val="1955DB"/>
-                </a:solidFill>
-                <a:latin typeface="Arial" pitchFamily="34" charset="0"/>
-                <a:ea typeface="Arial" pitchFamily="34" charset="-122"/>
-                <a:cs typeface="Arial" pitchFamily="34" charset="-120"/>
-              </a:rPr>
-              <a:t>Systems Analyst</a:t>
-            </a:r>
-            <a:endParaRPr lang="en-US" sz="2000" dirty="0"/>
-          </a:p>
-        </p:txBody>
-      </p:sp>
-      <p:sp>
-        <p:nvSpPr>
-          <p:cNvPr id="15" name="Text 13"/>
-          <p:cNvSpPr txBox="1"/>
-          <p:nvPr/>
-        </p:nvSpPr>
-        <p:spPr>
-          <a:xfrm>
-            <a:off x="6400800" y="3810000"/>
-            <a:ext cx="5048250" cy="762000"/>
-          </a:xfrm>
-          <a:prstGeom prst="rect">
-            <a:avLst/>
-          </a:prstGeom>
-          <a:noFill/>
-          <a:ln/>
-        </p:spPr>
-        <p:txBody>
-          <a:bodyPr wrap="square" lIns="0" tIns="0" rIns="0" bIns="0" rtlCol="0" anchor="t"/>
-          <a:lstStyle/>
-          <a:p>
-            <a:pPr indent="0" marL="0">
-              <a:buNone/>
-            </a:pPr>
-            <a:r>
-              <a:rPr lang="en-US" sz="1600" dirty="0">
-                <a:solidFill>
-                  <a:srgbClr val="191919"/>
-                </a:solidFill>
-                <a:latin typeface="Arial" pitchFamily="34" charset="0"/>
-                <a:ea typeface="Arial" pitchFamily="34" charset="-122"/>
-                <a:cs typeface="Arial" pitchFamily="34" charset="-120"/>
-              </a:rPr>
-              <a:t>Studies how an organization works and recommends technology changes; translates between tech and non-tech teams.</a:t>
-            </a:r>
-            <a:endParaRPr lang="en-US" sz="1600" dirty="0"/>
-          </a:p>
-        </p:txBody>
-      </p:sp>
-      <p:pic>
-        <p:nvPicPr>
-          <p:cNvPr id="16" name="Image 0" descr="/home/claude/cce/build/slides/1sw-wk3/assets/bls-netadmin.jpg">    </p:cNvPr>
-          <p:cNvPicPr>
-            <a:picLocks noChangeAspect="1"/>
-          </p:cNvPicPr>
-          <p:nvPr/>
-        </p:nvPicPr>
-        <p:blipFill>
-          <a:blip r:embed="rId1"/>
-          <a:stretch>
-            <a:fillRect/>
-          </a:stretch>
-        </p:blipFill>
-        <p:spPr>
-          <a:xfrm>
-            <a:off x="609600" y="4876800"/>
-            <a:ext cx="4362450" cy="1714500"/>
-          </a:xfrm>
-          <a:prstGeom prst="rect">
-            <a:avLst/>
-          </a:prstGeom>
-        </p:spPr>
-      </p:pic>
-      <p:sp>
-        <p:nvSpPr>
-          <p:cNvPr id="17" name="Text 14"/>
-          <p:cNvSpPr txBox="1"/>
-          <p:nvPr/>
-        </p:nvSpPr>
-        <p:spPr>
-          <a:xfrm>
-            <a:off x="5238750" y="4953000"/>
-            <a:ext cx="6343650" cy="1524000"/>
-          </a:xfrm>
-          <a:prstGeom prst="rect">
-            <a:avLst/>
-          </a:prstGeom>
-          <a:noFill/>
-          <a:ln/>
-        </p:spPr>
-        <p:txBody>
-          <a:bodyPr wrap="square" lIns="0" tIns="0" rIns="0" bIns="0" rtlCol="0" anchor="t"/>
-          <a:lstStyle/>
-          <a:p>
-            <a:pPr indent="0" marL="0">
-              <a:buNone/>
-            </a:pPr>
-            <a:r>
-              <a:rPr lang="en-US" sz="1600" dirty="0">
-                <a:solidFill>
-                  <a:srgbClr val="5F6368"/>
-                </a:solidFill>
-                <a:latin typeface="Arial" pitchFamily="34" charset="0"/>
-                <a:ea typeface="Arial" pitchFamily="34" charset="-122"/>
-                <a:cs typeface="Arial" pitchFamily="34" charset="-120"/>
-              </a:rPr>
-              <a:t>Where the cards come from: the BLS Occupational Outlook Handbook, the same site you will use on Day 4.</a:t>
-            </a:r>
-            <a:endParaRPr lang="en-US" sz="1600" dirty="0"/>
-          </a:p>
-          <a:p>
-            <a:pPr indent="0" marL="0">
-              <a:buNone/>
-            </a:pPr>
-            <a:r>
-              <a:rPr lang="en-US" sz="1600" dirty="0">
-                <a:solidFill>
-                  <a:srgbClr val="5F6368"/>
-                </a:solidFill>
-                <a:latin typeface="Arial" pitchFamily="34" charset="0"/>
-                <a:ea typeface="Arial" pitchFamily="34" charset="-122"/>
-                <a:cs typeface="Arial" pitchFamily="34" charset="-120"/>
-              </a:rPr>
-              <a:t>The cards give typical preparation for each career. Typical means common, not required by every employer.</a:t>
-            </a:r>
-            <a:endParaRPr lang="en-US" sz="1600" dirty="0"/>
+              <a:t>When it works, nobody notices. When it breaks, four kinds of people get called.</a:t>
+            </a:r>
+            <a:endParaRPr lang="en-US" sz="1900" dirty="0"/>
           </a:p>
         </p:txBody>
       </p:sp>
@@ -3319,7 +4075,7 @@
                 <a:ea typeface="Arial Black" pitchFamily="34" charset="-122"/>
                 <a:cs typeface="Arial Black" pitchFamily="34" charset="-120"/>
               </a:rPr>
-              <a:t>Compare the four roles</a:t>
+              <a:t>The four careers</a:t>
             </a:r>
             <a:endParaRPr lang="en-US" sz="4200" dirty="0"/>
           </a:p>
@@ -3358,7 +4114,7 @@
                 <a:ea typeface="Arial" pitchFamily="34" charset="-122"/>
                 <a:cs typeface="Arial" pitchFamily="34" charset="-120"/>
               </a:rPr>
-              <a:t>22 minutes · Voice 0 · Card set or notebook entry labeled 1SW Wk3 Networking</a:t>
+              <a:t>Networking Career Cards · link on the Day 1 page</a:t>
             </a:r>
             <a:endParaRPr lang="en-US" sz="2100" dirty="0"/>
           </a:p>
@@ -3373,7 +4129,7 @@
         <p:spPr>
           <a:xfrm>
             <a:off x="609600" y="1905000"/>
-            <a:ext cx="6858000" cy="1009650"/>
+            <a:ext cx="5372100" cy="1295400"/>
           </a:xfrm>
           <a:prstGeom prst="rect">
             <a:avLst/>
@@ -3397,34 +4153,34 @@
         </p:nvSpPr>
         <p:spPr>
           <a:xfrm>
-            <a:off x="838200" y="2019300"/>
-            <a:ext cx="1238250" cy="781050"/>
-          </a:xfrm>
-          <a:prstGeom prst="rect">
-            <a:avLst/>
-          </a:prstGeom>
-          <a:noFill/>
-          <a:ln/>
-        </p:spPr>
-        <p:txBody>
-          <a:bodyPr wrap="square" lIns="0" tIns="0" rIns="0" bIns="0" rtlCol="0" anchor="ctr"/>
-          <a:lstStyle/>
-          <a:p>
-            <a:pPr indent="0" marL="0">
-              <a:buNone/>
-            </a:pPr>
-            <a:r>
-              <a:rPr lang="en-US" sz="2200" b="1" dirty="0">
+            <a:off x="800100" y="2019300"/>
+            <a:ext cx="5048250" cy="323850"/>
+          </a:xfrm>
+          <a:prstGeom prst="rect">
+            <a:avLst/>
+          </a:prstGeom>
+          <a:noFill/>
+          <a:ln/>
+        </p:spPr>
+        <p:txBody>
+          <a:bodyPr wrap="square" lIns="0" tIns="0" rIns="0" bIns="0" rtlCol="0" anchor="t"/>
+          <a:lstStyle/>
+          <a:p>
+            <a:pPr indent="0" marL="0">
+              <a:buNone/>
+            </a:pPr>
+            <a:r>
+              <a:rPr lang="en-US" sz="2000" b="1" dirty="0">
                 <a:solidFill>
                   <a:srgbClr val="1955DB"/>
                 </a:solidFill>
-                <a:latin typeface="Arial Black" pitchFamily="34" charset="0"/>
-                <a:ea typeface="Arial Black" pitchFamily="34" charset="-122"/>
-                <a:cs typeface="Arial Black" pitchFamily="34" charset="-120"/>
-              </a:rPr>
-              <a:t>Task</a:t>
-            </a:r>
-            <a:endParaRPr lang="en-US" sz="2200" dirty="0"/>
+                <a:latin typeface="Arial" pitchFamily="34" charset="0"/>
+                <a:ea typeface="Arial" pitchFamily="34" charset="-122"/>
+                <a:cs typeface="Arial" pitchFamily="34" charset="-120"/>
+              </a:rPr>
+              <a:t>Network Administrator</a:t>
+            </a:r>
+            <a:endParaRPr lang="en-US" sz="2000" dirty="0"/>
           </a:p>
         </p:txBody>
       </p:sp>
@@ -3436,24 +4192,24 @@
         </p:nvSpPr>
         <p:spPr>
           <a:xfrm>
-            <a:off x="2190750" y="2019300"/>
-            <a:ext cx="5048250" cy="781050"/>
-          </a:xfrm>
-          <a:prstGeom prst="rect">
-            <a:avLst/>
-          </a:prstGeom>
-          <a:noFill/>
-          <a:ln/>
-        </p:spPr>
-        <p:txBody>
-          <a:bodyPr wrap="square" lIns="0" tIns="0" rIns="0" bIns="0" rtlCol="0" anchor="ctr"/>
-          <a:lstStyle/>
-          <a:p>
-            <a:pPr indent="0" marL="0">
-              <a:buNone/>
-            </a:pPr>
-            <a:r>
-              <a:rPr lang="en-US" sz="1800" dirty="0">
+            <a:off x="800100" y="2381250"/>
+            <a:ext cx="5048250" cy="762000"/>
+          </a:xfrm>
+          <a:prstGeom prst="rect">
+            <a:avLst/>
+          </a:prstGeom>
+          <a:noFill/>
+          <a:ln/>
+        </p:spPr>
+        <p:txBody>
+          <a:bodyPr wrap="square" lIns="0" tIns="0" rIns="0" bIns="0" rtlCol="0" anchor="t"/>
+          <a:lstStyle/>
+          <a:p>
+            <a:pPr indent="0" marL="0">
+              <a:buNone/>
+            </a:pPr>
+            <a:r>
+              <a:rPr lang="en-US" sz="1600" dirty="0">
                 <a:solidFill>
                   <a:srgbClr val="191919"/>
                 </a:solidFill>
@@ -3461,9 +4217,9 @@
                 <a:ea typeface="Arial" pitchFamily="34" charset="-122"/>
                 <a:cs typeface="Arial" pitchFamily="34" charset="-120"/>
               </a:rPr>
-              <a:t>One technical task this person does. Copy a verb from the card: monitor, back up, design, interview.</a:t>
-            </a:r>
-            <a:endParaRPr lang="en-US" sz="1800" dirty="0"/>
+              <a:t>Keeps the network running day to day: accounts, monitoring, troubleshooting, updates.</a:t>
+            </a:r>
+            <a:endParaRPr lang="en-US" sz="1600" dirty="0"/>
           </a:p>
         </p:txBody>
       </p:sp>
@@ -3475,8 +4231,8 @@
         </p:nvSpPr>
         <p:spPr>
           <a:xfrm>
-            <a:off x="609600" y="3048000"/>
-            <a:ext cx="6858000" cy="1009650"/>
+            <a:off x="6210300" y="1905000"/>
+            <a:ext cx="5372100" cy="1295400"/>
           </a:xfrm>
           <a:prstGeom prst="rect">
             <a:avLst/>
@@ -3500,34 +4256,34 @@
         </p:nvSpPr>
         <p:spPr>
           <a:xfrm>
-            <a:off x="838200" y="3162300"/>
-            <a:ext cx="1238250" cy="781050"/>
-          </a:xfrm>
-          <a:prstGeom prst="rect">
-            <a:avLst/>
-          </a:prstGeom>
-          <a:noFill/>
-          <a:ln/>
-        </p:spPr>
-        <p:txBody>
-          <a:bodyPr wrap="square" lIns="0" tIns="0" rIns="0" bIns="0" rtlCol="0" anchor="ctr"/>
-          <a:lstStyle/>
-          <a:p>
-            <a:pPr indent="0" marL="0">
-              <a:buNone/>
-            </a:pPr>
-            <a:r>
-              <a:rPr lang="en-US" sz="2200" b="1" dirty="0">
-                <a:solidFill>
-                  <a:srgbClr val="D71A65"/>
-                </a:solidFill>
-                <a:latin typeface="Arial Black" pitchFamily="34" charset="0"/>
-                <a:ea typeface="Arial Black" pitchFamily="34" charset="-122"/>
-                <a:cs typeface="Arial Black" pitchFamily="34" charset="-120"/>
-              </a:rPr>
-              <a:t>Skill</a:t>
-            </a:r>
-            <a:endParaRPr lang="en-US" sz="2200" dirty="0"/>
+            <a:off x="6400800" y="2019300"/>
+            <a:ext cx="5048250" cy="323850"/>
+          </a:xfrm>
+          <a:prstGeom prst="rect">
+            <a:avLst/>
+          </a:prstGeom>
+          <a:noFill/>
+          <a:ln/>
+        </p:spPr>
+        <p:txBody>
+          <a:bodyPr wrap="square" lIns="0" tIns="0" rIns="0" bIns="0" rtlCol="0" anchor="t"/>
+          <a:lstStyle/>
+          <a:p>
+            <a:pPr indent="0" marL="0">
+              <a:buNone/>
+            </a:pPr>
+            <a:r>
+              <a:rPr lang="en-US" sz="2000" b="1" dirty="0">
+                <a:solidFill>
+                  <a:srgbClr val="1955DB"/>
+                </a:solidFill>
+                <a:latin typeface="Arial" pitchFamily="34" charset="0"/>
+                <a:ea typeface="Arial" pitchFamily="34" charset="-122"/>
+                <a:cs typeface="Arial" pitchFamily="34" charset="-120"/>
+              </a:rPr>
+              <a:t>Network Architect</a:t>
+            </a:r>
+            <a:endParaRPr lang="en-US" sz="2000" dirty="0"/>
           </a:p>
         </p:txBody>
       </p:sp>
@@ -3539,24 +4295,24 @@
         </p:nvSpPr>
         <p:spPr>
           <a:xfrm>
-            <a:off x="2190750" y="3162300"/>
-            <a:ext cx="5048250" cy="781050"/>
-          </a:xfrm>
-          <a:prstGeom prst="rect">
-            <a:avLst/>
-          </a:prstGeom>
-          <a:noFill/>
-          <a:ln/>
-        </p:spPr>
-        <p:txBody>
-          <a:bodyPr wrap="square" lIns="0" tIns="0" rIns="0" bIns="0" rtlCol="0" anchor="ctr"/>
-          <a:lstStyle/>
-          <a:p>
-            <a:pPr indent="0" marL="0">
-              <a:buNone/>
-            </a:pPr>
-            <a:r>
-              <a:rPr lang="en-US" sz="1800" dirty="0">
+            <a:off x="6400800" y="2381250"/>
+            <a:ext cx="5048250" cy="762000"/>
+          </a:xfrm>
+          <a:prstGeom prst="rect">
+            <a:avLst/>
+          </a:prstGeom>
+          <a:noFill/>
+          <a:ln/>
+        </p:spPr>
+        <p:txBody>
+          <a:bodyPr wrap="square" lIns="0" tIns="0" rIns="0" bIns="0" rtlCol="0" anchor="t"/>
+          <a:lstStyle/>
+          <a:p>
+            <a:pPr indent="0" marL="0">
+              <a:buNone/>
+            </a:pPr>
+            <a:r>
+              <a:rPr lang="en-US" sz="1600" dirty="0">
                 <a:solidFill>
                   <a:srgbClr val="191919"/>
                 </a:solidFill>
@@ -3564,46 +4320,7 @@
                 <a:ea typeface="Arial" pitchFamily="34" charset="-122"/>
                 <a:cs typeface="Arial" pitchFamily="34" charset="-120"/>
               </a:rPr>
-              <a:t>One transferable skill this person needs, and why it matters in this job.</a:t>
-            </a:r>
-            <a:endParaRPr lang="en-US" sz="1800" dirty="0"/>
-          </a:p>
-        </p:txBody>
-      </p:sp>
-      <p:sp>
-        <p:nvSpPr>
-          <p:cNvPr id="10" name="Text 8"/>
-          <p:cNvSpPr txBox="1"/>
-          <p:nvPr/>
-        </p:nvSpPr>
-        <p:spPr>
-          <a:xfrm>
-            <a:off x="609600" y="4381500"/>
-            <a:ext cx="6858000" cy="666750"/>
-          </a:xfrm>
-          <a:prstGeom prst="rect">
-            <a:avLst/>
-          </a:prstGeom>
-          <a:noFill/>
-          <a:ln/>
-        </p:spPr>
-        <p:txBody>
-          <a:bodyPr wrap="square" lIns="0" tIns="0" rIns="0" bIns="0" rtlCol="0" anchor="t"/>
-          <a:lstStyle/>
-          <a:p>
-            <a:pPr indent="0" marL="0">
-              <a:buNone/>
-            </a:pPr>
-            <a:r>
-              <a:rPr lang="en-US" sz="1600" dirty="0">
-                <a:solidFill>
-                  <a:srgbClr val="5F6368"/>
-                </a:solidFill>
-                <a:latin typeface="Arial" pitchFamily="34" charset="0"/>
-                <a:ea typeface="Arial" pitchFamily="34" charset="-122"/>
-                <a:cs typeface="Arial" pitchFamily="34" charset="-120"/>
-              </a:rPr>
-              <a:t>Four rows: Network Administrator, Network Architect, Database Administrator, Systems Analyst. If you note a salary, keep the job title, place, and date next to it.</a:t>
+              <a:t>Plans and designs the network: equipment, capacity, security, cost tradeoffs.</a:t>
             </a:r>
             <a:endParaRPr lang="en-US" sz="1600" dirty="0"/>
           </a:p>
@@ -3611,14 +4328,14 @@
       </p:sp>
       <p:sp>
         <p:nvSpPr>
-          <p:cNvPr id="11" name="Shape 9"/>
+          <p:cNvPr id="10" name="Shape 8"/>
           <p:cNvSpPr/>
           <p:nvPr/>
         </p:nvSpPr>
         <p:spPr>
           <a:xfrm>
-            <a:off x="7810500" y="1905000"/>
-            <a:ext cx="3771900" cy="3048000"/>
+            <a:off x="609600" y="3333750"/>
+            <a:ext cx="5372100" cy="1295400"/>
           </a:xfrm>
           <a:prstGeom prst="rect">
             <a:avLst/>
@@ -3636,53 +4353,53 @@
       </p:sp>
       <p:sp>
         <p:nvSpPr>
+          <p:cNvPr id="11" name="Text 9"/>
+          <p:cNvSpPr txBox="1"/>
+          <p:nvPr/>
+        </p:nvSpPr>
+        <p:spPr>
+          <a:xfrm>
+            <a:off x="800100" y="3448050"/>
+            <a:ext cx="5048250" cy="323850"/>
+          </a:xfrm>
+          <a:prstGeom prst="rect">
+            <a:avLst/>
+          </a:prstGeom>
+          <a:noFill/>
+          <a:ln/>
+        </p:spPr>
+        <p:txBody>
+          <a:bodyPr wrap="square" lIns="0" tIns="0" rIns="0" bIns="0" rtlCol="0" anchor="t"/>
+          <a:lstStyle/>
+          <a:p>
+            <a:pPr indent="0" marL="0">
+              <a:buNone/>
+            </a:pPr>
+            <a:r>
+              <a:rPr lang="en-US" sz="2000" b="1" dirty="0">
+                <a:solidFill>
+                  <a:srgbClr val="1955DB"/>
+                </a:solidFill>
+                <a:latin typeface="Arial" pitchFamily="34" charset="0"/>
+                <a:ea typeface="Arial" pitchFamily="34" charset="-122"/>
+                <a:cs typeface="Arial" pitchFamily="34" charset="-120"/>
+              </a:rPr>
+              <a:t>Database Administrator</a:t>
+            </a:r>
+            <a:endParaRPr lang="en-US" sz="2000" dirty="0"/>
+          </a:p>
+        </p:txBody>
+      </p:sp>
+      <p:sp>
+        <p:nvSpPr>
           <p:cNvPr id="12" name="Text 10"/>
           <p:cNvSpPr txBox="1"/>
           <p:nvPr/>
         </p:nvSpPr>
         <p:spPr>
           <a:xfrm>
-            <a:off x="8039100" y="2038350"/>
-            <a:ext cx="3429000" cy="400050"/>
-          </a:xfrm>
-          <a:prstGeom prst="rect">
-            <a:avLst/>
-          </a:prstGeom>
-          <a:noFill/>
-          <a:ln/>
-        </p:spPr>
-        <p:txBody>
-          <a:bodyPr wrap="square" lIns="0" tIns="0" rIns="0" bIns="0" rtlCol="0" anchor="ctr"/>
-          <a:lstStyle/>
-          <a:p>
-            <a:pPr indent="0" marL="0">
-              <a:buNone/>
-            </a:pPr>
-            <a:r>
-              <a:rPr lang="en-US" sz="2300" b="1" dirty="0">
-                <a:solidFill>
-                  <a:srgbClr val="1955DB"/>
-                </a:solidFill>
-                <a:latin typeface="Arial Black" pitchFamily="34" charset="0"/>
-                <a:ea typeface="Arial Black" pitchFamily="34" charset="-122"/>
-                <a:cs typeface="Arial Black" pitchFamily="34" charset="-120"/>
-              </a:rPr>
-              <a:t>Skills to pick from</a:t>
-            </a:r>
-            <a:endParaRPr lang="en-US" sz="2300" dirty="0"/>
-          </a:p>
-        </p:txBody>
-      </p:sp>
-      <p:sp>
-        <p:nvSpPr>
-          <p:cNvPr id="13" name="Text 11"/>
-          <p:cNvSpPr txBox="1"/>
-          <p:nvPr/>
-        </p:nvSpPr>
-        <p:spPr>
-          <a:xfrm>
-            <a:off x="8039100" y="2457450"/>
-            <a:ext cx="3333750" cy="2381250"/>
+            <a:off x="800100" y="3810000"/>
+            <a:ext cx="5048250" cy="762000"/>
           </a:xfrm>
           <a:prstGeom prst="rect">
             <a:avLst/>
@@ -3698,7 +4415,7 @@
               <a:buNone/>
             </a:pPr>
             <a:r>
-              <a:rPr lang="en-US" sz="1800" dirty="0">
+              <a:rPr lang="en-US" sz="1600" dirty="0">
                 <a:solidFill>
                   <a:srgbClr val="191919"/>
                 </a:solidFill>
@@ -3706,134 +4423,32 @@
                 <a:ea typeface="Arial" pitchFamily="34" charset="-122"/>
                 <a:cs typeface="Arial" pitchFamily="34" charset="-120"/>
               </a:rPr>
-              <a:t>problem-solving</a:t>
-            </a:r>
-            <a:endParaRPr lang="en-US" sz="1800" dirty="0"/>
-          </a:p>
-          <a:p>
-            <a:pPr indent="0" marL="0">
-              <a:buNone/>
-            </a:pPr>
-            <a:r>
-              <a:rPr lang="en-US" sz="1800" dirty="0">
-                <a:solidFill>
-                  <a:srgbClr val="191919"/>
-                </a:solidFill>
-                <a:latin typeface="Arial" pitchFamily="34" charset="0"/>
-                <a:ea typeface="Arial" pitchFamily="34" charset="-122"/>
-                <a:cs typeface="Arial" pitchFamily="34" charset="-120"/>
-              </a:rPr>
-              <a:t>communication</a:t>
-            </a:r>
-            <a:endParaRPr lang="en-US" sz="1800" dirty="0"/>
-          </a:p>
-          <a:p>
-            <a:pPr indent="0" marL="0">
-              <a:buNone/>
-            </a:pPr>
-            <a:r>
-              <a:rPr lang="en-US" sz="1800" dirty="0">
-                <a:solidFill>
-                  <a:srgbClr val="191919"/>
-                </a:solidFill>
-                <a:latin typeface="Arial" pitchFamily="34" charset="0"/>
-                <a:ea typeface="Arial" pitchFamily="34" charset="-122"/>
-                <a:cs typeface="Arial" pitchFamily="34" charset="-120"/>
-              </a:rPr>
-              <a:t>attention to detail</a:t>
-            </a:r>
-            <a:endParaRPr lang="en-US" sz="1800" dirty="0"/>
-          </a:p>
-          <a:p>
-            <a:pPr indent="0" marL="0">
-              <a:buNone/>
-            </a:pPr>
-            <a:r>
-              <a:rPr lang="en-US" sz="1800" dirty="0">
-                <a:solidFill>
-                  <a:srgbClr val="191919"/>
-                </a:solidFill>
-                <a:latin typeface="Arial" pitchFamily="34" charset="0"/>
-                <a:ea typeface="Arial" pitchFamily="34" charset="-122"/>
-                <a:cs typeface="Arial" pitchFamily="34" charset="-120"/>
-              </a:rPr>
-              <a:t>time management</a:t>
-            </a:r>
-            <a:endParaRPr lang="en-US" sz="1800" dirty="0"/>
-          </a:p>
-          <a:p>
-            <a:pPr indent="0" marL="0">
-              <a:buNone/>
-            </a:pPr>
-            <a:r>
-              <a:rPr lang="en-US" sz="1800" dirty="0">
-                <a:solidFill>
-                  <a:srgbClr val="191919"/>
-                </a:solidFill>
-                <a:latin typeface="Arial" pitchFamily="34" charset="0"/>
-                <a:ea typeface="Arial" pitchFamily="34" charset="-122"/>
-                <a:cs typeface="Arial" pitchFamily="34" charset="-120"/>
-              </a:rPr>
-              <a:t>teamwork</a:t>
-            </a:r>
-            <a:endParaRPr lang="en-US" sz="1800" dirty="0"/>
-          </a:p>
-          <a:p>
-            <a:pPr indent="0" marL="0">
-              <a:buNone/>
-            </a:pPr>
-            <a:r>
-              <a:rPr lang="en-US" sz="1800" dirty="0">
-                <a:solidFill>
-                  <a:srgbClr val="191919"/>
-                </a:solidFill>
-                <a:latin typeface="Arial" pitchFamily="34" charset="0"/>
-                <a:ea typeface="Arial" pitchFamily="34" charset="-122"/>
-                <a:cs typeface="Arial" pitchFamily="34" charset="-120"/>
-              </a:rPr>
-              <a:t>curiosity</a:t>
-            </a:r>
-            <a:endParaRPr lang="en-US" sz="1800" dirty="0"/>
-          </a:p>
-          <a:p>
-            <a:pPr indent="0" marL="0">
-              <a:buNone/>
-            </a:pPr>
-            <a:r>
-              <a:rPr lang="en-US" sz="1800" dirty="0">
-                <a:solidFill>
-                  <a:srgbClr val="191919"/>
-                </a:solidFill>
-                <a:latin typeface="Arial" pitchFamily="34" charset="0"/>
-                <a:ea typeface="Arial" pitchFamily="34" charset="-122"/>
-                <a:cs typeface="Arial" pitchFamily="34" charset="-120"/>
-              </a:rPr>
-              <a:t>patience under pressure</a:t>
-            </a:r>
-            <a:endParaRPr lang="en-US" sz="1800" dirty="0"/>
-          </a:p>
-        </p:txBody>
-      </p:sp>
-      <p:sp>
-        <p:nvSpPr>
-          <p:cNvPr id="14" name="Shape 12"/>
+              <a:t>Organizes, protects, and backs up data so users get reliable answers.</a:t>
+            </a:r>
+            <a:endParaRPr lang="en-US" sz="1600" dirty="0"/>
+          </a:p>
+        </p:txBody>
+      </p:sp>
+      <p:sp>
+        <p:nvSpPr>
+          <p:cNvPr id="13" name="Shape 11"/>
           <p:cNvSpPr/>
           <p:nvPr/>
         </p:nvSpPr>
         <p:spPr>
           <a:xfrm>
-            <a:off x="609600" y="5238750"/>
-            <a:ext cx="10972800" cy="762000"/>
+            <a:off x="6210300" y="3333750"/>
+            <a:ext cx="5372100" cy="1295400"/>
           </a:xfrm>
           <a:prstGeom prst="rect">
             <a:avLst/>
           </a:prstGeom>
           <a:solidFill>
-            <a:srgbClr val="F4D941"/>
+            <a:srgbClr val="FFFFFF"/>
           </a:solidFill>
           <a:ln w="12700">
             <a:solidFill>
-              <a:srgbClr val="F4D941"/>
+              <a:srgbClr val="FFFFFF"/>
             </a:solidFill>
             <a:prstDash val="solid"/>
           </a:ln>
@@ -3841,30 +4456,69 @@
       </p:sp>
       <p:sp>
         <p:nvSpPr>
+          <p:cNvPr id="14" name="Text 12"/>
+          <p:cNvSpPr txBox="1"/>
+          <p:nvPr/>
+        </p:nvSpPr>
+        <p:spPr>
+          <a:xfrm>
+            <a:off x="6400800" y="3448050"/>
+            <a:ext cx="5048250" cy="323850"/>
+          </a:xfrm>
+          <a:prstGeom prst="rect">
+            <a:avLst/>
+          </a:prstGeom>
+          <a:noFill/>
+          <a:ln/>
+        </p:spPr>
+        <p:txBody>
+          <a:bodyPr wrap="square" lIns="0" tIns="0" rIns="0" bIns="0" rtlCol="0" anchor="t"/>
+          <a:lstStyle/>
+          <a:p>
+            <a:pPr indent="0" marL="0">
+              <a:buNone/>
+            </a:pPr>
+            <a:r>
+              <a:rPr lang="en-US" sz="2000" b="1" dirty="0">
+                <a:solidFill>
+                  <a:srgbClr val="1955DB"/>
+                </a:solidFill>
+                <a:latin typeface="Arial" pitchFamily="34" charset="0"/>
+                <a:ea typeface="Arial" pitchFamily="34" charset="-122"/>
+                <a:cs typeface="Arial" pitchFamily="34" charset="-120"/>
+              </a:rPr>
+              <a:t>Systems Analyst</a:t>
+            </a:r>
+            <a:endParaRPr lang="en-US" sz="2000" dirty="0"/>
+          </a:p>
+        </p:txBody>
+      </p:sp>
+      <p:sp>
+        <p:nvSpPr>
           <p:cNvPr id="15" name="Text 13"/>
           <p:cNvSpPr txBox="1"/>
           <p:nvPr/>
         </p:nvSpPr>
         <p:spPr>
           <a:xfrm>
-            <a:off x="800100" y="5391150"/>
-            <a:ext cx="10591800" cy="457200"/>
-          </a:xfrm>
-          <a:prstGeom prst="rect">
-            <a:avLst/>
-          </a:prstGeom>
-          <a:noFill/>
-          <a:ln/>
-        </p:spPr>
-        <p:txBody>
-          <a:bodyPr wrap="square" lIns="0" tIns="0" rIns="0" bIns="0" rtlCol="0" anchor="ctr"/>
-          <a:lstStyle/>
-          <a:p>
-            <a:pPr indent="0" marL="0">
-              <a:buNone/>
-            </a:pPr>
-            <a:r>
-              <a:rPr lang="en-US" sz="1700" b="1" dirty="0">
+            <a:off x="6400800" y="3810000"/>
+            <a:ext cx="5048250" cy="762000"/>
+          </a:xfrm>
+          <a:prstGeom prst="rect">
+            <a:avLst/>
+          </a:prstGeom>
+          <a:noFill/>
+          <a:ln/>
+        </p:spPr>
+        <p:txBody>
+          <a:bodyPr wrap="square" lIns="0" tIns="0" rIns="0" bIns="0" rtlCol="0" anchor="t"/>
+          <a:lstStyle/>
+          <a:p>
+            <a:pPr indent="0" marL="0">
+              <a:buNone/>
+            </a:pPr>
+            <a:r>
+              <a:rPr lang="en-US" sz="1600" dirty="0">
                 <a:solidFill>
                   <a:srgbClr val="191919"/>
                 </a:solidFill>
@@ -3872,9 +4526,72 @@
                 <a:ea typeface="Arial" pitchFamily="34" charset="-122"/>
                 <a:cs typeface="Arial" pitchFamily="34" charset="-120"/>
               </a:rPr>
-              <a:t>Finished early? Find Your Future p. 38: open Hats &amp; Ladders, Clusters, Information Technology, and do the App Exploration checklist.</a:t>
-            </a:r>
-            <a:endParaRPr lang="en-US" sz="1700" dirty="0"/>
+              <a:t>Studies how an organization works and recommends technology changes; translates between tech and non-tech teams.</a:t>
+            </a:r>
+            <a:endParaRPr lang="en-US" sz="1600" dirty="0"/>
+          </a:p>
+        </p:txBody>
+      </p:sp>
+      <p:pic>
+        <p:nvPicPr>
+          <p:cNvPr id="16" name="Image 0" descr="/home/claude/cce/build/slides/1sw-wk3/assets/bls-netadmin.jpg">    </p:cNvPr>
+          <p:cNvPicPr>
+            <a:picLocks noChangeAspect="1"/>
+          </p:cNvPicPr>
+          <p:nvPr/>
+        </p:nvPicPr>
+        <p:blipFill>
+          <a:blip r:embed="rId1"/>
+          <a:stretch>
+            <a:fillRect/>
+          </a:stretch>
+        </p:blipFill>
+        <p:spPr>
+          <a:xfrm>
+            <a:off x="609600" y="4876800"/>
+            <a:ext cx="4362450" cy="1714500"/>
+          </a:xfrm>
+          <a:prstGeom prst="rect">
+            <a:avLst/>
+          </a:prstGeom>
+        </p:spPr>
+      </p:pic>
+      <p:sp>
+        <p:nvSpPr>
+          <p:cNvPr id="17" name="Text 14"/>
+          <p:cNvSpPr txBox="1"/>
+          <p:nvPr/>
+        </p:nvSpPr>
+        <p:spPr>
+          <a:xfrm>
+            <a:off x="5238750" y="4953000"/>
+            <a:ext cx="5715000" cy="381000"/>
+          </a:xfrm>
+          <a:prstGeom prst="rect">
+            <a:avLst/>
+          </a:prstGeom>
+          <a:noFill/>
+          <a:ln/>
+        </p:spPr>
+        <p:txBody>
+          <a:bodyPr wrap="square" lIns="0" tIns="0" rIns="0" bIns="0" rtlCol="0" anchor="t"/>
+          <a:lstStyle/>
+          <a:p>
+            <a:pPr indent="0" marL="0">
+              <a:buNone/>
+            </a:pPr>
+            <a:r>
+              <a:rPr lang="en-US" sz="1600" dirty="0">
+                <a:solidFill>
+                  <a:srgbClr val="5F6368"/>
+                </a:solidFill>
+                <a:latin typeface="Arial" pitchFamily="34" charset="0"/>
+                <a:ea typeface="Arial" pitchFamily="34" charset="-122"/>
+                <a:cs typeface="Arial" pitchFamily="34" charset="-120"/>
+              </a:rPr>
+              <a:t>From the BLS Occupational Outlook Handbook.</a:t>
+            </a:r>
+            <a:endParaRPr lang="en-US" sz="1600" dirty="0"/>
           </a:p>
         </p:txBody>
       </p:sp>
@@ -3943,7 +4660,7 @@
                 <a:ea typeface="Arial Black" pitchFamily="34" charset="-122"/>
                 <a:cs typeface="Arial Black" pitchFamily="34" charset="-120"/>
               </a:rPr>
-              <a:t>What transfers?</a:t>
+              <a:t>Who gets called?</a:t>
             </a:r>
             <a:endParaRPr lang="en-US" sz="4200" dirty="0"/>
           </a:p>
@@ -3982,7 +4699,7 @@
                 <a:ea typeface="Arial" pitchFamily="34" charset="-122"/>
                 <a:cs typeface="Arial" pitchFamily="34" charset="-120"/>
               </a:rPr>
-              <a:t>A transferable skill moves with you from job to job</a:t>
+              <a:t>30 seconds with a partner · Voice 1</a:t>
             </a:r>
             <a:endParaRPr lang="en-US" sz="2100" dirty="0"/>
           </a:p>
@@ -3997,7 +4714,7 @@
         <p:spPr>
           <a:xfrm>
             <a:off x="609600" y="1905000"/>
-            <a:ext cx="5372100" cy="2857500"/>
+            <a:ext cx="10972800" cy="1619250"/>
           </a:xfrm>
           <a:prstGeom prst="rect">
             <a:avLst/>
@@ -4021,8 +4738,47 @@
         </p:nvSpPr>
         <p:spPr>
           <a:xfrm>
-            <a:off x="838200" y="2038350"/>
-            <a:ext cx="4953000" cy="400050"/>
+            <a:off x="876300" y="2133600"/>
+            <a:ext cx="10477500" cy="1238250"/>
+          </a:xfrm>
+          <a:prstGeom prst="rect">
+            <a:avLst/>
+          </a:prstGeom>
+          <a:noFill/>
+          <a:ln/>
+        </p:spPr>
+        <p:txBody>
+          <a:bodyPr wrap="square" lIns="0" tIns="0" rIns="0" bIns="0" rtlCol="0" anchor="t"/>
+          <a:lstStyle/>
+          <a:p>
+            <a:pPr indent="0" marL="0">
+              <a:buNone/>
+            </a:pPr>
+            <a:r>
+              <a:rPr lang="en-US" sz="2400" b="1" dirty="0">
+                <a:solidFill>
+                  <a:srgbClr val="191919"/>
+                </a:solidFill>
+                <a:latin typeface="Arial" pitchFamily="34" charset="0"/>
+                <a:ea typeface="Arial" pitchFamily="34" charset="-122"/>
+                <a:cs typeface="Arial" pitchFamily="34" charset="-120"/>
+              </a:rPr>
+              <a:t>The Wi-Fi is down Monday morning. Which of the four gets called first? Which one designed the network in the first place? Which one would notice if student data went missing?</a:t>
+            </a:r>
+            <a:endParaRPr lang="en-US" sz="2400" dirty="0"/>
+          </a:p>
+        </p:txBody>
+      </p:sp>
+      <p:sp>
+        <p:nvSpPr>
+          <p:cNvPr id="6" name="Text 4"/>
+          <p:cNvSpPr txBox="1"/>
+          <p:nvPr/>
+        </p:nvSpPr>
+        <p:spPr>
+          <a:xfrm>
+            <a:off x="609600" y="3810000"/>
+            <a:ext cx="5715000" cy="400050"/>
           </a:xfrm>
           <a:prstGeom prst="rect">
             <a:avLst/>
@@ -4040,13 +4796,13 @@
             <a:r>
               <a:rPr lang="en-US" sz="2300" b="1" dirty="0">
                 <a:solidFill>
-                  <a:srgbClr val="D71A65"/>
+                  <a:srgbClr val="1955DB"/>
                 </a:solidFill>
                 <a:latin typeface="Arial Black" pitchFamily="34" charset="0"/>
                 <a:ea typeface="Arial Black" pitchFamily="34" charset="-122"/>
                 <a:cs typeface="Arial Black" pitchFamily="34" charset="-120"/>
               </a:rPr>
-              <a:t>Technical skill</a:t>
+              <a:t>Say it like this</a:t>
             </a:r>
             <a:endParaRPr lang="en-US" sz="2300" dirty="0"/>
           </a:p>
@@ -4054,14 +4810,14 @@
       </p:sp>
       <p:sp>
         <p:nvSpPr>
-          <p:cNvPr id="6" name="Text 4"/>
-          <p:cNvSpPr txBox="1"/>
-          <p:nvPr/>
-        </p:nvSpPr>
-        <p:spPr>
-          <a:xfrm>
-            <a:off x="838200" y="2457450"/>
-            <a:ext cx="4953000" cy="2095500"/>
+          <p:cNvPr id="7" name="Text 5"/>
+          <p:cNvSpPr txBox="1"/>
+          <p:nvPr/>
+        </p:nvSpPr>
+        <p:spPr>
+          <a:xfrm>
+            <a:off x="609600" y="4248150"/>
+            <a:ext cx="10953750" cy="571500"/>
           </a:xfrm>
           <a:prstGeom prst="rect">
             <a:avLst/>
@@ -4077,7 +4833,7 @@
               <a:buNone/>
             </a:pPr>
             <a:r>
-              <a:rPr lang="en-US" sz="2000" dirty="0">
+              <a:rPr lang="en-US" sz="2400" dirty="0">
                 <a:solidFill>
                   <a:srgbClr val="191919"/>
                 </a:solidFill>
@@ -4085,53 +4841,11 @@
                 <a:ea typeface="Arial" pitchFamily="34" charset="-122"/>
                 <a:cs typeface="Arial" pitchFamily="34" charset="-120"/>
               </a:rPr>
-              <a:t>Belongs to one job.</a:t>
-            </a:r>
-            <a:endParaRPr lang="en-US" sz="2000" dirty="0"/>
-          </a:p>
-          <a:p>
-            <a:pPr indent="0" marL="0">
-              <a:buNone/>
-            </a:pPr>
-            <a:r>
-              <a:rPr lang="en-US" sz="2000" dirty="0">
-                <a:solidFill>
-                  <a:srgbClr val="191919"/>
-                </a:solidFill>
-                <a:latin typeface="Arial" pitchFamily="34" charset="0"/>
-                <a:ea typeface="Arial" pitchFamily="34" charset="-122"/>
-                <a:cs typeface="Arial" pitchFamily="34" charset="-120"/>
-              </a:rPr>
-              <a:t>Configure a router. Restore a database backup. Write a network diagram.</a:t>
-            </a:r>
-            <a:endParaRPr lang="en-US" sz="2000" dirty="0"/>
-          </a:p>
-        </p:txBody>
-      </p:sp>
-      <p:sp>
-        <p:nvSpPr>
-          <p:cNvPr id="7" name="Shape 5"/>
-          <p:cNvSpPr/>
-          <p:nvPr/>
-        </p:nvSpPr>
-        <p:spPr>
-          <a:xfrm>
-            <a:off x="6210300" y="1905000"/>
-            <a:ext cx="5372100" cy="2857500"/>
-          </a:xfrm>
-          <a:prstGeom prst="rect">
-            <a:avLst/>
-          </a:prstGeom>
-          <a:solidFill>
-            <a:srgbClr val="FFFFFF"/>
-          </a:solidFill>
-          <a:ln w="12700">
-            <a:solidFill>
-              <a:srgbClr val="FFFFFF"/>
-            </a:solidFill>
-            <a:prstDash val="solid"/>
-          </a:ln>
-        </p:spPr>
+              <a:t>The ________ gets called first because their job is to ________.</a:t>
+            </a:r>
+            <a:endParaRPr lang="en-US" sz="2400" dirty="0"/>
+          </a:p>
+        </p:txBody>
       </p:sp>
       <p:sp>
         <p:nvSpPr>
@@ -4141,47 +4855,8 @@
         </p:nvSpPr>
         <p:spPr>
           <a:xfrm>
-            <a:off x="6438900" y="2038350"/>
-            <a:ext cx="4953000" cy="400050"/>
-          </a:xfrm>
-          <a:prstGeom prst="rect">
-            <a:avLst/>
-          </a:prstGeom>
-          <a:noFill/>
-          <a:ln/>
-        </p:spPr>
-        <p:txBody>
-          <a:bodyPr wrap="square" lIns="0" tIns="0" rIns="0" bIns="0" rtlCol="0" anchor="ctr"/>
-          <a:lstStyle/>
-          <a:p>
-            <a:pPr indent="0" marL="0">
-              <a:buNone/>
-            </a:pPr>
-            <a:r>
-              <a:rPr lang="en-US" sz="2300" b="1" dirty="0">
-                <a:solidFill>
-                  <a:srgbClr val="1E7A46"/>
-                </a:solidFill>
-                <a:latin typeface="Arial Black" pitchFamily="34" charset="0"/>
-                <a:ea typeface="Arial Black" pitchFamily="34" charset="-122"/>
-                <a:cs typeface="Arial Black" pitchFamily="34" charset="-120"/>
-              </a:rPr>
-              <a:t>Transferable skill</a:t>
-            </a:r>
-            <a:endParaRPr lang="en-US" sz="2300" dirty="0"/>
-          </a:p>
-        </p:txBody>
-      </p:sp>
-      <p:sp>
-        <p:nvSpPr>
-          <p:cNvPr id="9" name="Text 7"/>
-          <p:cNvSpPr txBox="1"/>
-          <p:nvPr/>
-        </p:nvSpPr>
-        <p:spPr>
-          <a:xfrm>
-            <a:off x="6438900" y="2457450"/>
-            <a:ext cx="4953000" cy="2095500"/>
+            <a:off x="609600" y="4953000"/>
+            <a:ext cx="10953750" cy="381000"/>
           </a:xfrm>
           <a:prstGeom prst="rect">
             <a:avLst/>
@@ -4197,73 +4872,17 @@
               <a:buNone/>
             </a:pPr>
             <a:r>
-              <a:rPr lang="en-US" sz="2000" dirty="0">
-                <a:solidFill>
-                  <a:srgbClr val="191919"/>
-                </a:solidFill>
-                <a:latin typeface="Arial" pitchFamily="34" charset="0"/>
-                <a:ea typeface="Arial" pitchFamily="34" charset="-122"/>
-                <a:cs typeface="Arial" pitchFamily="34" charset="-120"/>
-              </a:rPr>
-              <a:t>Goes with you anywhere.</a:t>
-            </a:r>
-            <a:endParaRPr lang="en-US" sz="2000" dirty="0"/>
-          </a:p>
-          <a:p>
-            <a:pPr indent="0" marL="0">
-              <a:buNone/>
-            </a:pPr>
-            <a:r>
-              <a:rPr lang="en-US" sz="2000" dirty="0">
-                <a:solidFill>
-                  <a:srgbClr val="191919"/>
-                </a:solidFill>
-                <a:latin typeface="Arial" pitchFamily="34" charset="0"/>
-                <a:ea typeface="Arial" pitchFamily="34" charset="-122"/>
-                <a:cs typeface="Arial" pitchFamily="34" charset="-120"/>
-              </a:rPr>
-              <a:t>Explain a problem to someone who is not technical. Notice the small detail that breaks everything. Stay calm when the system is down.</a:t>
-            </a:r>
-            <a:endParaRPr lang="en-US" sz="2000" dirty="0"/>
-          </a:p>
-        </p:txBody>
-      </p:sp>
-      <p:sp>
-        <p:nvSpPr>
-          <p:cNvPr id="10" name="Text 8"/>
-          <p:cNvSpPr txBox="1"/>
-          <p:nvPr/>
-        </p:nvSpPr>
-        <p:spPr>
-          <a:xfrm>
-            <a:off x="609600" y="5048250"/>
-            <a:ext cx="10953750" cy="476250"/>
-          </a:xfrm>
-          <a:prstGeom prst="rect">
-            <a:avLst/>
-          </a:prstGeom>
-          <a:noFill/>
-          <a:ln/>
-        </p:spPr>
-        <p:txBody>
-          <a:bodyPr wrap="square" lIns="0" tIns="0" rIns="0" bIns="0" rtlCol="0" anchor="t"/>
-          <a:lstStyle/>
-          <a:p>
-            <a:pPr indent="0" marL="0">
-              <a:buNone/>
-            </a:pPr>
-            <a:r>
-              <a:rPr lang="en-US" sz="2200" b="1" dirty="0">
-                <a:solidFill>
-                  <a:srgbClr val="191919"/>
-                </a:solidFill>
-                <a:latin typeface="Arial" pitchFamily="34" charset="0"/>
-                <a:ea typeface="Arial" pitchFamily="34" charset="-122"/>
-                <a:cs typeface="Arial" pitchFamily="34" charset="-120"/>
-              </a:rPr>
-              <a:t>Employers hire for the technical skill. They keep people for the transferable ones.</a:t>
-            </a:r>
-            <a:endParaRPr lang="en-US" sz="2200" dirty="0"/>
+              <a:rPr lang="en-US" sz="1700" dirty="0">
+                <a:solidFill>
+                  <a:srgbClr val="5F6368"/>
+                </a:solidFill>
+                <a:latin typeface="Arial" pitchFamily="34" charset="0"/>
+                <a:ea typeface="Arial" pitchFamily="34" charset="-122"/>
+                <a:cs typeface="Arial" pitchFamily="34" charset="-120"/>
+              </a:rPr>
+              <a:t>Two pairs share. Then open the cards.</a:t>
+            </a:r>
+            <a:endParaRPr lang="en-US" sz="1700" dirty="0"/>
           </a:p>
         </p:txBody>
       </p:sp>
@@ -4332,7 +4951,7 @@
                 <a:ea typeface="Arial Black" pitchFamily="34" charset="-122"/>
                 <a:cs typeface="Arial Black" pitchFamily="34" charset="-120"/>
               </a:rPr>
-              <a:t>Stop and Jot</a:t>
+              <a:t>Compare the four roles</a:t>
             </a:r>
             <a:endParaRPr lang="en-US" sz="4200" dirty="0"/>
           </a:p>
@@ -4371,7 +4990,7 @@
                 <a:ea typeface="Arial" pitchFamily="34" charset="-122"/>
                 <a:cs typeface="Arial" pitchFamily="34" charset="-120"/>
               </a:rPr>
-              <a:t>60 seconds · Voice 0 · In your notebook</a:t>
+              <a:t>22 minutes · Voice 0 · Card set or notebook entry labeled 1SW Wk3 Networking</a:t>
             </a:r>
             <a:endParaRPr lang="en-US" sz="2100" dirty="0"/>
           </a:p>
@@ -4386,7 +5005,7 @@
         <p:spPr>
           <a:xfrm>
             <a:off x="609600" y="1905000"/>
-            <a:ext cx="10972800" cy="1619250"/>
+            <a:ext cx="6858000" cy="1009650"/>
           </a:xfrm>
           <a:prstGeom prst="rect">
             <a:avLst/>
@@ -4410,64 +5029,8 @@
         </p:nvSpPr>
         <p:spPr>
           <a:xfrm>
-            <a:off x="876300" y="2133600"/>
-            <a:ext cx="10477500" cy="1238250"/>
-          </a:xfrm>
-          <a:prstGeom prst="rect">
-            <a:avLst/>
-          </a:prstGeom>
-          <a:noFill/>
-          <a:ln/>
-        </p:spPr>
-        <p:txBody>
-          <a:bodyPr wrap="square" lIns="0" tIns="0" rIns="0" bIns="0" rtlCol="0" anchor="t"/>
-          <a:lstStyle/>
-          <a:p>
-            <a:pPr indent="0" marL="0">
-              <a:buNone/>
-            </a:pPr>
-            <a:r>
-              <a:rPr lang="en-US" sz="2600" b="1" dirty="0">
-                <a:solidFill>
-                  <a:srgbClr val="191919"/>
-                </a:solidFill>
-                <a:latin typeface="Arial" pitchFamily="34" charset="0"/>
-                <a:ea typeface="Arial" pitchFamily="34" charset="-122"/>
-                <a:cs typeface="Arial" pitchFamily="34" charset="-120"/>
-              </a:rPr>
-              <a:t>Pick a skill from your rows that TWO of the four careers need.</a:t>
-            </a:r>
-            <a:endParaRPr lang="en-US" sz="2600" dirty="0"/>
-          </a:p>
-          <a:p>
-            <a:pPr indent="0" marL="0">
-              <a:buNone/>
-            </a:pPr>
-            <a:r>
-              <a:rPr lang="en-US" sz="2600" b="1" dirty="0">
-                <a:solidFill>
-                  <a:srgbClr val="191919"/>
-                </a:solidFill>
-                <a:latin typeface="Arial" pitchFamily="34" charset="0"/>
-                <a:ea typeface="Arial" pitchFamily="34" charset="-122"/>
-                <a:cs typeface="Arial" pitchFamily="34" charset="-120"/>
-              </a:rPr>
-              <a:t>Write one complete sentence.</a:t>
-            </a:r>
-            <a:endParaRPr lang="en-US" sz="2600" dirty="0"/>
-          </a:p>
-        </p:txBody>
-      </p:sp>
-      <p:sp>
-        <p:nvSpPr>
-          <p:cNvPr id="6" name="Text 4"/>
-          <p:cNvSpPr txBox="1"/>
-          <p:nvPr/>
-        </p:nvSpPr>
-        <p:spPr>
-          <a:xfrm>
-            <a:off x="609600" y="3810000"/>
-            <a:ext cx="5715000" cy="400050"/>
+            <a:off x="838200" y="2019300"/>
+            <a:ext cx="1238250" cy="781050"/>
           </a:xfrm>
           <a:prstGeom prst="rect">
             <a:avLst/>
@@ -4483,7 +5046,7 @@
               <a:buNone/>
             </a:pPr>
             <a:r>
-              <a:rPr lang="en-US" sz="2300" b="1" dirty="0">
+              <a:rPr lang="en-US" sz="2200" b="1" dirty="0">
                 <a:solidFill>
                   <a:srgbClr val="1955DB"/>
                 </a:solidFill>
@@ -4491,38 +5054,38 @@
                 <a:ea typeface="Arial Black" pitchFamily="34" charset="-122"/>
                 <a:cs typeface="Arial Black" pitchFamily="34" charset="-120"/>
               </a:rPr>
-              <a:t>Say it like this</a:t>
-            </a:r>
-            <a:endParaRPr lang="en-US" sz="2300" dirty="0"/>
-          </a:p>
-        </p:txBody>
-      </p:sp>
-      <p:sp>
-        <p:nvSpPr>
-          <p:cNvPr id="7" name="Text 5"/>
-          <p:cNvSpPr txBox="1"/>
-          <p:nvPr/>
-        </p:nvSpPr>
-        <p:spPr>
-          <a:xfrm>
-            <a:off x="609600" y="4248150"/>
-            <a:ext cx="10953750" cy="571500"/>
-          </a:xfrm>
-          <a:prstGeom prst="rect">
-            <a:avLst/>
-          </a:prstGeom>
-          <a:noFill/>
-          <a:ln/>
-        </p:spPr>
-        <p:txBody>
-          <a:bodyPr wrap="square" lIns="0" tIns="0" rIns="0" bIns="0" rtlCol="0" anchor="t"/>
-          <a:lstStyle/>
-          <a:p>
-            <a:pPr indent="0" marL="0">
-              <a:buNone/>
-            </a:pPr>
-            <a:r>
-              <a:rPr lang="en-US" sz="2400" dirty="0">
+              <a:t>Task</a:t>
+            </a:r>
+            <a:endParaRPr lang="en-US" sz="2200" dirty="0"/>
+          </a:p>
+        </p:txBody>
+      </p:sp>
+      <p:sp>
+        <p:nvSpPr>
+          <p:cNvPr id="6" name="Text 4"/>
+          <p:cNvSpPr txBox="1"/>
+          <p:nvPr/>
+        </p:nvSpPr>
+        <p:spPr>
+          <a:xfrm>
+            <a:off x="2190750" y="2019300"/>
+            <a:ext cx="5048250" cy="781050"/>
+          </a:xfrm>
+          <a:prstGeom prst="rect">
+            <a:avLst/>
+          </a:prstGeom>
+          <a:noFill/>
+          <a:ln/>
+        </p:spPr>
+        <p:txBody>
+          <a:bodyPr wrap="square" lIns="0" tIns="0" rIns="0" bIns="0" rtlCol="0" anchor="ctr"/>
+          <a:lstStyle/>
+          <a:p>
+            <a:pPr indent="0" marL="0">
+              <a:buNone/>
+            </a:pPr>
+            <a:r>
+              <a:rPr lang="en-US" sz="1800" dirty="0">
                 <a:solidFill>
                   <a:srgbClr val="191919"/>
                 </a:solidFill>
@@ -4530,28 +5093,36 @@
                 <a:ea typeface="Arial" pitchFamily="34" charset="-122"/>
                 <a:cs typeface="Arial" pitchFamily="34" charset="-120"/>
               </a:rPr>
-              <a:t>________ transfers across ________ and ________</a:t>
-            </a:r>
-            <a:endParaRPr lang="en-US" sz="2400" dirty="0"/>
-          </a:p>
-          <a:p>
-            <a:pPr indent="0" marL="0">
-              <a:buNone/>
-            </a:pPr>
-            <a:r>
-              <a:rPr lang="en-US" sz="2400" dirty="0">
-                <a:solidFill>
-                  <a:srgbClr val="191919"/>
-                </a:solidFill>
-                <a:latin typeface="Arial" pitchFamily="34" charset="0"/>
-                <a:ea typeface="Arial" pitchFamily="34" charset="-122"/>
-                <a:cs typeface="Arial" pitchFamily="34" charset="-120"/>
-              </a:rPr>
-              <a:t>because both workers must ________.</a:t>
-            </a:r>
-            <a:endParaRPr lang="en-US" sz="2400" dirty="0"/>
-          </a:p>
-        </p:txBody>
+              <a:t>One technical task this person does. Copy a verb from the card: monitor, back up, design, interview.</a:t>
+            </a:r>
+            <a:endParaRPr lang="en-US" sz="1800" dirty="0"/>
+          </a:p>
+        </p:txBody>
+      </p:sp>
+      <p:sp>
+        <p:nvSpPr>
+          <p:cNvPr id="7" name="Shape 5"/>
+          <p:cNvSpPr/>
+          <p:nvPr/>
+        </p:nvSpPr>
+        <p:spPr>
+          <a:xfrm>
+            <a:off x="609600" y="3048000"/>
+            <a:ext cx="6858000" cy="1009650"/>
+          </a:xfrm>
+          <a:prstGeom prst="rect">
+            <a:avLst/>
+          </a:prstGeom>
+          <a:solidFill>
+            <a:srgbClr val="FFFFFF"/>
+          </a:solidFill>
+          <a:ln w="12700">
+            <a:solidFill>
+              <a:srgbClr val="FFFFFF"/>
+            </a:solidFill>
+            <a:prstDash val="solid"/>
+          </a:ln>
+        </p:spPr>
       </p:sp>
       <p:sp>
         <p:nvSpPr>
@@ -4561,8 +5132,8 @@
         </p:nvSpPr>
         <p:spPr>
           <a:xfrm>
-            <a:off x="609600" y="5334000"/>
-            <a:ext cx="5715000" cy="400050"/>
+            <a:off x="838200" y="3162300"/>
+            <a:ext cx="1238250" cy="781050"/>
           </a:xfrm>
           <a:prstGeom prst="rect">
             <a:avLst/>
@@ -4578,15 +5149,157 @@
               <a:buNone/>
             </a:pPr>
             <a:r>
-              <a:rPr lang="en-US" sz="2300" b="1" dirty="0">
-                <a:solidFill>
-                  <a:srgbClr val="1955DB"/>
+              <a:rPr lang="en-US" sz="2200" b="1" dirty="0">
+                <a:solidFill>
+                  <a:srgbClr val="D71A65"/>
                 </a:solidFill>
                 <a:latin typeface="Arial Black" pitchFamily="34" charset="0"/>
                 <a:ea typeface="Arial Black" pitchFamily="34" charset="-122"/>
                 <a:cs typeface="Arial Black" pitchFamily="34" charset="-120"/>
               </a:rPr>
-              <a:t>Words you will need</a:t>
+              <a:t>Skill</a:t>
+            </a:r>
+            <a:endParaRPr lang="en-US" sz="2200" dirty="0"/>
+          </a:p>
+        </p:txBody>
+      </p:sp>
+      <p:sp>
+        <p:nvSpPr>
+          <p:cNvPr id="9" name="Text 7"/>
+          <p:cNvSpPr txBox="1"/>
+          <p:nvPr/>
+        </p:nvSpPr>
+        <p:spPr>
+          <a:xfrm>
+            <a:off x="2190750" y="3162300"/>
+            <a:ext cx="5048250" cy="781050"/>
+          </a:xfrm>
+          <a:prstGeom prst="rect">
+            <a:avLst/>
+          </a:prstGeom>
+          <a:noFill/>
+          <a:ln/>
+        </p:spPr>
+        <p:txBody>
+          <a:bodyPr wrap="square" lIns="0" tIns="0" rIns="0" bIns="0" rtlCol="0" anchor="ctr"/>
+          <a:lstStyle/>
+          <a:p>
+            <a:pPr indent="0" marL="0">
+              <a:buNone/>
+            </a:pPr>
+            <a:r>
+              <a:rPr lang="en-US" sz="1800" dirty="0">
+                <a:solidFill>
+                  <a:srgbClr val="191919"/>
+                </a:solidFill>
+                <a:latin typeface="Arial" pitchFamily="34" charset="0"/>
+                <a:ea typeface="Arial" pitchFamily="34" charset="-122"/>
+                <a:cs typeface="Arial" pitchFamily="34" charset="-120"/>
+              </a:rPr>
+              <a:t>One transferable skill this person needs, and why it matters in this job.</a:t>
+            </a:r>
+            <a:endParaRPr lang="en-US" sz="1800" dirty="0"/>
+          </a:p>
+        </p:txBody>
+      </p:sp>
+      <p:sp>
+        <p:nvSpPr>
+          <p:cNvPr id="10" name="Text 8"/>
+          <p:cNvSpPr txBox="1"/>
+          <p:nvPr/>
+        </p:nvSpPr>
+        <p:spPr>
+          <a:xfrm>
+            <a:off x="609600" y="4381500"/>
+            <a:ext cx="6858000" cy="381000"/>
+          </a:xfrm>
+          <a:prstGeom prst="rect">
+            <a:avLst/>
+          </a:prstGeom>
+          <a:noFill/>
+          <a:ln/>
+        </p:spPr>
+        <p:txBody>
+          <a:bodyPr wrap="square" lIns="0" tIns="0" rIns="0" bIns="0" rtlCol="0" anchor="t"/>
+          <a:lstStyle/>
+          <a:p>
+            <a:pPr indent="0" marL="0">
+              <a:buNone/>
+            </a:pPr>
+            <a:r>
+              <a:rPr lang="en-US" sz="1600" dirty="0">
+                <a:solidFill>
+                  <a:srgbClr val="5F6368"/>
+                </a:solidFill>
+                <a:latin typeface="Arial" pitchFamily="34" charset="0"/>
+                <a:ea typeface="Arial" pitchFamily="34" charset="-122"/>
+                <a:cs typeface="Arial" pitchFamily="34" charset="-120"/>
+              </a:rPr>
+              <a:t>Four rows: Network Administrator, Network Architect, Database Administrator, Systems Analyst.</a:t>
+            </a:r>
+            <a:endParaRPr lang="en-US" sz="1600" dirty="0"/>
+          </a:p>
+        </p:txBody>
+      </p:sp>
+      <p:sp>
+        <p:nvSpPr>
+          <p:cNvPr id="11" name="Shape 9"/>
+          <p:cNvSpPr/>
+          <p:nvPr/>
+        </p:nvSpPr>
+        <p:spPr>
+          <a:xfrm>
+            <a:off x="7810500" y="1905000"/>
+            <a:ext cx="3771900" cy="3048000"/>
+          </a:xfrm>
+          <a:prstGeom prst="rect">
+            <a:avLst/>
+          </a:prstGeom>
+          <a:solidFill>
+            <a:srgbClr val="FFFFFF"/>
+          </a:solidFill>
+          <a:ln w="12700">
+            <a:solidFill>
+              <a:srgbClr val="FFFFFF"/>
+            </a:solidFill>
+            <a:prstDash val="solid"/>
+          </a:ln>
+        </p:spPr>
+      </p:sp>
+      <p:sp>
+        <p:nvSpPr>
+          <p:cNvPr id="12" name="Text 10"/>
+          <p:cNvSpPr txBox="1"/>
+          <p:nvPr/>
+        </p:nvSpPr>
+        <p:spPr>
+          <a:xfrm>
+            <a:off x="8039100" y="2038350"/>
+            <a:ext cx="3429000" cy="400050"/>
+          </a:xfrm>
+          <a:prstGeom prst="rect">
+            <a:avLst/>
+          </a:prstGeom>
+          <a:noFill/>
+          <a:ln/>
+        </p:spPr>
+        <p:txBody>
+          <a:bodyPr wrap="square" lIns="0" tIns="0" rIns="0" bIns="0" rtlCol="0" anchor="ctr"/>
+          <a:lstStyle/>
+          <a:p>
+            <a:pPr indent="0" marL="0">
+              <a:buNone/>
+            </a:pPr>
+            <a:r>
+              <a:rPr lang="en-US" sz="2300" b="1" dirty="0">
+                <a:solidFill>
+                  <a:srgbClr val="1955DB"/>
+                </a:solidFill>
+                <a:latin typeface="Arial Black" pitchFamily="34" charset="0"/>
+                <a:ea typeface="Arial Black" pitchFamily="34" charset="-122"/>
+                <a:cs typeface="Arial Black" pitchFamily="34" charset="-120"/>
+              </a:rPr>
+              <a:t>Skills to pick from</a:t>
             </a:r>
             <a:endParaRPr lang="en-US" sz="2300" dirty="0"/>
           </a:p>
@@ -4594,14 +5307,14 @@
       </p:sp>
       <p:sp>
         <p:nvSpPr>
-          <p:cNvPr id="9" name="Text 7"/>
-          <p:cNvSpPr txBox="1"/>
-          <p:nvPr/>
-        </p:nvSpPr>
-        <p:spPr>
-          <a:xfrm>
-            <a:off x="609600" y="5772150"/>
-            <a:ext cx="10953750" cy="476250"/>
+          <p:cNvPr id="13" name="Text 11"/>
+          <p:cNvSpPr txBox="1"/>
+          <p:nvPr/>
+        </p:nvSpPr>
+        <p:spPr>
+          <a:xfrm>
+            <a:off x="8039100" y="2457450"/>
+            <a:ext cx="3333750" cy="2381250"/>
           </a:xfrm>
           <a:prstGeom prst="rect">
             <a:avLst/>
@@ -4617,7 +5330,7 @@
               <a:buNone/>
             </a:pPr>
             <a:r>
-              <a:rPr lang="en-US" sz="2000" dirty="0">
+              <a:rPr lang="en-US" sz="1800" dirty="0">
                 <a:solidFill>
                   <a:srgbClr val="191919"/>
                 </a:solidFill>
@@ -4625,9 +5338,175 @@
                 <a:ea typeface="Arial" pitchFamily="34" charset="-122"/>
                 <a:cs typeface="Arial" pitchFamily="34" charset="-120"/>
               </a:rPr>
-              <a:t>problem-solving  ·  communication  ·  attention to detail  ·  time management  ·  teamwork  ·  curiosity  ·  patience under pressure</a:t>
-            </a:r>
-            <a:endParaRPr lang="en-US" sz="2000" dirty="0"/>
+              <a:t>problem-solving</a:t>
+            </a:r>
+            <a:endParaRPr lang="en-US" sz="1800" dirty="0"/>
+          </a:p>
+          <a:p>
+            <a:pPr indent="0" marL="0">
+              <a:buNone/>
+            </a:pPr>
+            <a:r>
+              <a:rPr lang="en-US" sz="1800" dirty="0">
+                <a:solidFill>
+                  <a:srgbClr val="191919"/>
+                </a:solidFill>
+                <a:latin typeface="Arial" pitchFamily="34" charset="0"/>
+                <a:ea typeface="Arial" pitchFamily="34" charset="-122"/>
+                <a:cs typeface="Arial" pitchFamily="34" charset="-120"/>
+              </a:rPr>
+              <a:t>communication</a:t>
+            </a:r>
+            <a:endParaRPr lang="en-US" sz="1800" dirty="0"/>
+          </a:p>
+          <a:p>
+            <a:pPr indent="0" marL="0">
+              <a:buNone/>
+            </a:pPr>
+            <a:r>
+              <a:rPr lang="en-US" sz="1800" dirty="0">
+                <a:solidFill>
+                  <a:srgbClr val="191919"/>
+                </a:solidFill>
+                <a:latin typeface="Arial" pitchFamily="34" charset="0"/>
+                <a:ea typeface="Arial" pitchFamily="34" charset="-122"/>
+                <a:cs typeface="Arial" pitchFamily="34" charset="-120"/>
+              </a:rPr>
+              <a:t>attention to detail</a:t>
+            </a:r>
+            <a:endParaRPr lang="en-US" sz="1800" dirty="0"/>
+          </a:p>
+          <a:p>
+            <a:pPr indent="0" marL="0">
+              <a:buNone/>
+            </a:pPr>
+            <a:r>
+              <a:rPr lang="en-US" sz="1800" dirty="0">
+                <a:solidFill>
+                  <a:srgbClr val="191919"/>
+                </a:solidFill>
+                <a:latin typeface="Arial" pitchFamily="34" charset="0"/>
+                <a:ea typeface="Arial" pitchFamily="34" charset="-122"/>
+                <a:cs typeface="Arial" pitchFamily="34" charset="-120"/>
+              </a:rPr>
+              <a:t>time management</a:t>
+            </a:r>
+            <a:endParaRPr lang="en-US" sz="1800" dirty="0"/>
+          </a:p>
+          <a:p>
+            <a:pPr indent="0" marL="0">
+              <a:buNone/>
+            </a:pPr>
+            <a:r>
+              <a:rPr lang="en-US" sz="1800" dirty="0">
+                <a:solidFill>
+                  <a:srgbClr val="191919"/>
+                </a:solidFill>
+                <a:latin typeface="Arial" pitchFamily="34" charset="0"/>
+                <a:ea typeface="Arial" pitchFamily="34" charset="-122"/>
+                <a:cs typeface="Arial" pitchFamily="34" charset="-120"/>
+              </a:rPr>
+              <a:t>teamwork</a:t>
+            </a:r>
+            <a:endParaRPr lang="en-US" sz="1800" dirty="0"/>
+          </a:p>
+          <a:p>
+            <a:pPr indent="0" marL="0">
+              <a:buNone/>
+            </a:pPr>
+            <a:r>
+              <a:rPr lang="en-US" sz="1800" dirty="0">
+                <a:solidFill>
+                  <a:srgbClr val="191919"/>
+                </a:solidFill>
+                <a:latin typeface="Arial" pitchFamily="34" charset="0"/>
+                <a:ea typeface="Arial" pitchFamily="34" charset="-122"/>
+                <a:cs typeface="Arial" pitchFamily="34" charset="-120"/>
+              </a:rPr>
+              <a:t>curiosity</a:t>
+            </a:r>
+            <a:endParaRPr lang="en-US" sz="1800" dirty="0"/>
+          </a:p>
+          <a:p>
+            <a:pPr indent="0" marL="0">
+              <a:buNone/>
+            </a:pPr>
+            <a:r>
+              <a:rPr lang="en-US" sz="1800" dirty="0">
+                <a:solidFill>
+                  <a:srgbClr val="191919"/>
+                </a:solidFill>
+                <a:latin typeface="Arial" pitchFamily="34" charset="0"/>
+                <a:ea typeface="Arial" pitchFamily="34" charset="-122"/>
+                <a:cs typeface="Arial" pitchFamily="34" charset="-120"/>
+              </a:rPr>
+              <a:t>patience under pressure</a:t>
+            </a:r>
+            <a:endParaRPr lang="en-US" sz="1800" dirty="0"/>
+          </a:p>
+        </p:txBody>
+      </p:sp>
+      <p:sp>
+        <p:nvSpPr>
+          <p:cNvPr id="14" name="Shape 12"/>
+          <p:cNvSpPr/>
+          <p:nvPr/>
+        </p:nvSpPr>
+        <p:spPr>
+          <a:xfrm>
+            <a:off x="609600" y="5238750"/>
+            <a:ext cx="10972800" cy="762000"/>
+          </a:xfrm>
+          <a:prstGeom prst="rect">
+            <a:avLst/>
+          </a:prstGeom>
+          <a:solidFill>
+            <a:srgbClr val="F4D941"/>
+          </a:solidFill>
+          <a:ln w="12700">
+            <a:solidFill>
+              <a:srgbClr val="F4D941"/>
+            </a:solidFill>
+            <a:prstDash val="solid"/>
+          </a:ln>
+        </p:spPr>
+      </p:sp>
+      <p:sp>
+        <p:nvSpPr>
+          <p:cNvPr id="15" name="Text 13"/>
+          <p:cNvSpPr txBox="1"/>
+          <p:nvPr/>
+        </p:nvSpPr>
+        <p:spPr>
+          <a:xfrm>
+            <a:off x="800100" y="5391150"/>
+            <a:ext cx="10591800" cy="457200"/>
+          </a:xfrm>
+          <a:prstGeom prst="rect">
+            <a:avLst/>
+          </a:prstGeom>
+          <a:noFill/>
+          <a:ln/>
+        </p:spPr>
+        <p:txBody>
+          <a:bodyPr wrap="square" lIns="0" tIns="0" rIns="0" bIns="0" rtlCol="0" anchor="ctr"/>
+          <a:lstStyle/>
+          <a:p>
+            <a:pPr indent="0" marL="0">
+              <a:buNone/>
+            </a:pPr>
+            <a:r>
+              <a:rPr lang="en-US" sz="1700" b="1" dirty="0">
+                <a:solidFill>
+                  <a:srgbClr val="191919"/>
+                </a:solidFill>
+                <a:latin typeface="Arial" pitchFamily="34" charset="0"/>
+                <a:ea typeface="Arial" pitchFamily="34" charset="-122"/>
+                <a:cs typeface="Arial" pitchFamily="34" charset="-120"/>
+              </a:rPr>
+              <a:t>Finished early? Find Your Future p. 38: open Hats &amp; Ladders, Clusters, Information Technology, and do the App Exploration checklist.</a:t>
+            </a:r>
+            <a:endParaRPr lang="en-US" sz="1700" dirty="0"/>
           </a:p>
         </p:txBody>
       </p:sp>
@@ -4688,7 +5567,7 @@
               <a:buNone/>
             </a:pPr>
             <a:r>
-              <a:rPr lang="en-US" sz="3600" b="1" dirty="0">
+              <a:rPr lang="en-US" sz="4200" b="1" dirty="0">
                 <a:solidFill>
                   <a:srgbClr val="191919"/>
                 </a:solidFill>
@@ -4696,9 +5575,9 @@
                 <a:ea typeface="Arial Black" pitchFamily="34" charset="-122"/>
                 <a:cs typeface="Arial Black" pitchFamily="34" charset="-120"/>
               </a:rPr>
-              <a:t>Exit ticket: programming vs. networking</a:t>
-            </a:r>
-            <a:endParaRPr lang="en-US" sz="3600" dirty="0"/>
+              <a:t>What transfers?</a:t>
+            </a:r>
+            <a:endParaRPr lang="en-US" sz="4200" dirty="0"/>
           </a:p>
         </p:txBody>
       </p:sp>
@@ -4735,7 +5614,7 @@
                 <a:ea typeface="Arial" pitchFamily="34" charset="-122"/>
                 <a:cs typeface="Arial" pitchFamily="34" charset="-120"/>
               </a:rPr>
-              <a:t>Open the Day 1 exit ticket on the Canvas page · 8 minutes</a:t>
+              <a:t>A transferable skill moves with you from job to job</a:t>
             </a:r>
             <a:endParaRPr lang="en-US" sz="2100" dirty="0"/>
           </a:p>
@@ -4750,7 +5629,7 @@
         <p:spPr>
           <a:xfrm>
             <a:off x="609600" y="1905000"/>
-            <a:ext cx="6858000" cy="3143250"/>
+            <a:ext cx="5372100" cy="2857500"/>
           </a:xfrm>
           <a:prstGeom prst="rect">
             <a:avLst/>
@@ -4774,217 +5653,8 @@
         </p:nvSpPr>
         <p:spPr>
           <a:xfrm>
-            <a:off x="838200" y="2057400"/>
-            <a:ext cx="6477000" cy="857250"/>
-          </a:xfrm>
-          <a:prstGeom prst="rect">
-            <a:avLst/>
-          </a:prstGeom>
-          <a:noFill/>
-          <a:ln/>
-        </p:spPr>
-        <p:txBody>
-          <a:bodyPr wrap="square" lIns="0" tIns="0" rIns="0" bIns="0" rtlCol="0" anchor="t"/>
-          <a:lstStyle/>
-          <a:p>
-            <a:pPr indent="0" marL="0">
-              <a:buNone/>
-            </a:pPr>
-            <a:r>
-              <a:rPr lang="en-US" sz="1900" dirty="0">
-                <a:solidFill>
-                  <a:srgbClr val="191919"/>
-                </a:solidFill>
-                <a:latin typeface="Arial" pitchFamily="34" charset="0"/>
-                <a:ea typeface="Arial" pitchFamily="34" charset="-122"/>
-                <a:cs typeface="Arial" pitchFamily="34" charset="-120"/>
-              </a:rPr>
-              <a:t>Pick one programming career from Week 2 (Software Dev, Web Dev, App Dev, or Game Dev).</a:t>
-            </a:r>
-            <a:endParaRPr lang="en-US" sz="1900" dirty="0"/>
-          </a:p>
-          <a:p>
-            <a:pPr indent="0" marL="0">
-              <a:buNone/>
-            </a:pPr>
-            <a:r>
-              <a:rPr lang="en-US" sz="1900" dirty="0">
-                <a:solidFill>
-                  <a:srgbClr val="191919"/>
-                </a:solidFill>
-                <a:latin typeface="Arial" pitchFamily="34" charset="0"/>
-                <a:ea typeface="Arial" pitchFamily="34" charset="-122"/>
-                <a:cs typeface="Arial" pitchFamily="34" charset="-120"/>
-              </a:rPr>
-              <a:t>Pick one networking career from today.</a:t>
-            </a:r>
-            <a:endParaRPr lang="en-US" sz="1900" dirty="0"/>
-          </a:p>
-        </p:txBody>
-      </p:sp>
-      <p:sp>
-        <p:nvSpPr>
-          <p:cNvPr id="6" name="Text 4"/>
-          <p:cNvSpPr txBox="1"/>
-          <p:nvPr/>
-        </p:nvSpPr>
-        <p:spPr>
-          <a:xfrm>
-            <a:off x="838200" y="3009900"/>
-            <a:ext cx="6477000" cy="1905000"/>
-          </a:xfrm>
-          <a:prstGeom prst="rect">
-            <a:avLst/>
-          </a:prstGeom>
-          <a:noFill/>
-          <a:ln/>
-        </p:spPr>
-        <p:txBody>
-          <a:bodyPr wrap="square" lIns="0" tIns="0" rIns="0" bIns="0" rtlCol="0" anchor="t"/>
-          <a:lstStyle/>
-          <a:p>
-            <a:pPr indent="0" marL="0">
-              <a:buNone/>
-            </a:pPr>
-            <a:r>
-              <a:rPr lang="en-US" sz="1800" dirty="0">
-                <a:solidFill>
-                  <a:srgbClr val="191919"/>
-                </a:solidFill>
-                <a:latin typeface="Arial" pitchFamily="34" charset="0"/>
-                <a:ea typeface="Arial" pitchFamily="34" charset="-122"/>
-                <a:cs typeface="Arial" pitchFamily="34" charset="-120"/>
-              </a:rPr>
-              <a:t>Left: 2 skills only the programmer uses.</a:t>
-            </a:r>
-            <a:endParaRPr lang="en-US" sz="1800" dirty="0"/>
-          </a:p>
-          <a:p>
-            <a:pPr indent="0" marL="0">
-              <a:buNone/>
-            </a:pPr>
-            <a:r>
-              <a:rPr lang="en-US" sz="1800" dirty="0">
-                <a:solidFill>
-                  <a:srgbClr val="191919"/>
-                </a:solidFill>
-                <a:latin typeface="Arial" pitchFamily="34" charset="0"/>
-                <a:ea typeface="Arial" pitchFamily="34" charset="-122"/>
-                <a:cs typeface="Arial" pitchFamily="34" charset="-120"/>
-              </a:rPr>
-              <a:t>Right: 2 skills only the networking career uses.</a:t>
-            </a:r>
-            <a:endParaRPr lang="en-US" sz="1800" dirty="0"/>
-          </a:p>
-          <a:p>
-            <a:pPr indent="0" marL="0">
-              <a:buNone/>
-            </a:pPr>
-            <a:r>
-              <a:rPr lang="en-US" sz="1800" dirty="0">
-                <a:solidFill>
-                  <a:srgbClr val="191919"/>
-                </a:solidFill>
-                <a:latin typeface="Arial" pitchFamily="34" charset="0"/>
-                <a:ea typeface="Arial" pitchFamily="34" charset="-122"/>
-                <a:cs typeface="Arial" pitchFamily="34" charset="-120"/>
-              </a:rPr>
-              <a:t>Middle: 2 skills BOTH need (soft skills, not technical).</a:t>
-            </a:r>
-            <a:endParaRPr lang="en-US" sz="1800" dirty="0"/>
-          </a:p>
-          <a:p>
-            <a:pPr indent="0" marL="0">
-              <a:buNone/>
-            </a:pPr>
-            <a:r>
-              <a:rPr lang="en-US" sz="1800" dirty="0">
-                <a:solidFill>
-                  <a:srgbClr val="191919"/>
-                </a:solidFill>
-                <a:latin typeface="Arial" pitchFamily="34" charset="0"/>
-                <a:ea typeface="Arial" pitchFamily="34" charset="-122"/>
-                <a:cs typeface="Arial" pitchFamily="34" charset="-120"/>
-              </a:rPr>
-              <a:t>Bottom line: why do employers care about the middle as much as the technical sides? One sentence.</a:t>
-            </a:r>
-            <a:endParaRPr lang="en-US" sz="1800" dirty="0"/>
-          </a:p>
-        </p:txBody>
-      </p:sp>
-      <p:pic>
-        <p:nvPicPr>
-          <p:cNvPr id="7" name="Image 0" descr="/home/claude/cce/build/slides/1sw-wk3/assets/cv-d1-exit.png">    </p:cNvPr>
-          <p:cNvPicPr>
-            <a:picLocks noChangeAspect="1"/>
-          </p:cNvPicPr>
-          <p:nvPr/>
-        </p:nvPicPr>
-        <p:blipFill>
-          <a:blip r:embed="rId1"/>
-          <a:stretch>
-            <a:fillRect/>
-          </a:stretch>
-        </p:blipFill>
-        <p:spPr>
-          <a:xfrm>
-            <a:off x="7810500" y="1905000"/>
-            <a:ext cx="3771900" cy="1333500"/>
-          </a:xfrm>
-          <a:prstGeom prst="rect">
-            <a:avLst/>
-          </a:prstGeom>
-        </p:spPr>
-      </p:pic>
-      <p:sp>
-        <p:nvSpPr>
-          <p:cNvPr id="8" name="Text 5"/>
-          <p:cNvSpPr txBox="1"/>
-          <p:nvPr/>
-        </p:nvSpPr>
-        <p:spPr>
-          <a:xfrm>
-            <a:off x="7810500" y="3333750"/>
-            <a:ext cx="3771900" cy="381000"/>
-          </a:xfrm>
-          <a:prstGeom prst="rect">
-            <a:avLst/>
-          </a:prstGeom>
-          <a:noFill/>
-          <a:ln/>
-        </p:spPr>
-        <p:txBody>
-          <a:bodyPr wrap="square" lIns="0" tIns="0" rIns="0" bIns="0" rtlCol="0" anchor="t"/>
-          <a:lstStyle/>
-          <a:p>
-            <a:pPr indent="0" marL="0">
-              <a:buNone/>
-            </a:pPr>
-            <a:r>
-              <a:rPr lang="en-US" sz="1500" dirty="0">
-                <a:solidFill>
-                  <a:srgbClr val="5F6368"/>
-                </a:solidFill>
-                <a:latin typeface="Arial" pitchFamily="34" charset="0"/>
-                <a:ea typeface="Arial" pitchFamily="34" charset="-122"/>
-                <a:cs typeface="Arial" pitchFamily="34" charset="-120"/>
-              </a:rPr>
-              <a:t>The button opens your own copy of the Venn diagram.</a:t>
-            </a:r>
-            <a:endParaRPr lang="en-US" sz="1500" dirty="0"/>
-          </a:p>
-        </p:txBody>
-      </p:sp>
-      <p:sp>
-        <p:nvSpPr>
-          <p:cNvPr id="9" name="Text 6"/>
-          <p:cNvSpPr txBox="1"/>
-          <p:nvPr/>
-        </p:nvSpPr>
-        <p:spPr>
-          <a:xfrm>
-            <a:off x="609600" y="5334000"/>
-            <a:ext cx="5715000" cy="400050"/>
+            <a:off x="838200" y="2038350"/>
+            <a:ext cx="4953000" cy="400050"/>
           </a:xfrm>
           <a:prstGeom prst="rect">
             <a:avLst/>
@@ -5002,13 +5672,13 @@
             <a:r>
               <a:rPr lang="en-US" sz="2300" b="1" dirty="0">
                 <a:solidFill>
-                  <a:srgbClr val="1955DB"/>
+                  <a:srgbClr val="D71A65"/>
                 </a:solidFill>
                 <a:latin typeface="Arial Black" pitchFamily="34" charset="0"/>
                 <a:ea typeface="Arial Black" pitchFamily="34" charset="-122"/>
                 <a:cs typeface="Arial Black" pitchFamily="34" charset="-120"/>
               </a:rPr>
-              <a:t>Say it like this</a:t>
+              <a:t>Technical skill</a:t>
             </a:r>
             <a:endParaRPr lang="en-US" sz="2300" dirty="0"/>
           </a:p>
@@ -5016,14 +5686,14 @@
       </p:sp>
       <p:sp>
         <p:nvSpPr>
-          <p:cNvPr id="10" name="Text 7"/>
-          <p:cNvSpPr txBox="1"/>
-          <p:nvPr/>
-        </p:nvSpPr>
-        <p:spPr>
-          <a:xfrm>
-            <a:off x="609600" y="5772150"/>
-            <a:ext cx="10953750" cy="571500"/>
+          <p:cNvPr id="6" name="Text 4"/>
+          <p:cNvSpPr txBox="1"/>
+          <p:nvPr/>
+        </p:nvSpPr>
+        <p:spPr>
+          <a:xfrm>
+            <a:off x="838200" y="2457450"/>
+            <a:ext cx="4953000" cy="2095500"/>
           </a:xfrm>
           <a:prstGeom prst="rect">
             <a:avLst/>
@@ -5039,7 +5709,7 @@
               <a:buNone/>
             </a:pPr>
             <a:r>
-              <a:rPr lang="en-US" sz="2400" dirty="0">
+              <a:rPr lang="en-US" sz="2000" dirty="0">
                 <a:solidFill>
                   <a:srgbClr val="191919"/>
                 </a:solidFill>
@@ -5047,9 +5717,185 @@
                 <a:ea typeface="Arial" pitchFamily="34" charset="-122"/>
                 <a:cs typeface="Arial" pitchFamily="34" charset="-120"/>
               </a:rPr>
-              <a:t>Employers care about ________ because ________.</a:t>
-            </a:r>
-            <a:endParaRPr lang="en-US" sz="2400" dirty="0"/>
+              <a:t>Belongs to one job.</a:t>
+            </a:r>
+            <a:endParaRPr lang="en-US" sz="2000" dirty="0"/>
+          </a:p>
+          <a:p>
+            <a:pPr indent="0" marL="0">
+              <a:buNone/>
+            </a:pPr>
+            <a:r>
+              <a:rPr lang="en-US" sz="2000" dirty="0">
+                <a:solidFill>
+                  <a:srgbClr val="191919"/>
+                </a:solidFill>
+                <a:latin typeface="Arial" pitchFamily="34" charset="0"/>
+                <a:ea typeface="Arial" pitchFamily="34" charset="-122"/>
+                <a:cs typeface="Arial" pitchFamily="34" charset="-120"/>
+              </a:rPr>
+              <a:t>Configure a router. Restore a database backup. Write a network diagram.</a:t>
+            </a:r>
+            <a:endParaRPr lang="en-US" sz="2000" dirty="0"/>
+          </a:p>
+        </p:txBody>
+      </p:sp>
+      <p:sp>
+        <p:nvSpPr>
+          <p:cNvPr id="7" name="Shape 5"/>
+          <p:cNvSpPr/>
+          <p:nvPr/>
+        </p:nvSpPr>
+        <p:spPr>
+          <a:xfrm>
+            <a:off x="6210300" y="1905000"/>
+            <a:ext cx="5372100" cy="2857500"/>
+          </a:xfrm>
+          <a:prstGeom prst="rect">
+            <a:avLst/>
+          </a:prstGeom>
+          <a:solidFill>
+            <a:srgbClr val="FFFFFF"/>
+          </a:solidFill>
+          <a:ln w="12700">
+            <a:solidFill>
+              <a:srgbClr val="FFFFFF"/>
+            </a:solidFill>
+            <a:prstDash val="solid"/>
+          </a:ln>
+        </p:spPr>
+      </p:sp>
+      <p:sp>
+        <p:nvSpPr>
+          <p:cNvPr id="8" name="Text 6"/>
+          <p:cNvSpPr txBox="1"/>
+          <p:nvPr/>
+        </p:nvSpPr>
+        <p:spPr>
+          <a:xfrm>
+            <a:off x="6438900" y="2038350"/>
+            <a:ext cx="4953000" cy="400050"/>
+          </a:xfrm>
+          <a:prstGeom prst="rect">
+            <a:avLst/>
+          </a:prstGeom>
+          <a:noFill/>
+          <a:ln/>
+        </p:spPr>
+        <p:txBody>
+          <a:bodyPr wrap="square" lIns="0" tIns="0" rIns="0" bIns="0" rtlCol="0" anchor="ctr"/>
+          <a:lstStyle/>
+          <a:p>
+            <a:pPr indent="0" marL="0">
+              <a:buNone/>
+            </a:pPr>
+            <a:r>
+              <a:rPr lang="en-US" sz="2300" b="1" dirty="0">
+                <a:solidFill>
+                  <a:srgbClr val="1E7A46"/>
+                </a:solidFill>
+                <a:latin typeface="Arial Black" pitchFamily="34" charset="0"/>
+                <a:ea typeface="Arial Black" pitchFamily="34" charset="-122"/>
+                <a:cs typeface="Arial Black" pitchFamily="34" charset="-120"/>
+              </a:rPr>
+              <a:t>Transferable skill</a:t>
+            </a:r>
+            <a:endParaRPr lang="en-US" sz="2300" dirty="0"/>
+          </a:p>
+        </p:txBody>
+      </p:sp>
+      <p:sp>
+        <p:nvSpPr>
+          <p:cNvPr id="9" name="Text 7"/>
+          <p:cNvSpPr txBox="1"/>
+          <p:nvPr/>
+        </p:nvSpPr>
+        <p:spPr>
+          <a:xfrm>
+            <a:off x="6438900" y="2457450"/>
+            <a:ext cx="4953000" cy="2095500"/>
+          </a:xfrm>
+          <a:prstGeom prst="rect">
+            <a:avLst/>
+          </a:prstGeom>
+          <a:noFill/>
+          <a:ln/>
+        </p:spPr>
+        <p:txBody>
+          <a:bodyPr wrap="square" lIns="0" tIns="0" rIns="0" bIns="0" rtlCol="0" anchor="t"/>
+          <a:lstStyle/>
+          <a:p>
+            <a:pPr indent="0" marL="0">
+              <a:buNone/>
+            </a:pPr>
+            <a:r>
+              <a:rPr lang="en-US" sz="2000" dirty="0">
+                <a:solidFill>
+                  <a:srgbClr val="191919"/>
+                </a:solidFill>
+                <a:latin typeface="Arial" pitchFamily="34" charset="0"/>
+                <a:ea typeface="Arial" pitchFamily="34" charset="-122"/>
+                <a:cs typeface="Arial" pitchFamily="34" charset="-120"/>
+              </a:rPr>
+              <a:t>Goes with you anywhere.</a:t>
+            </a:r>
+            <a:endParaRPr lang="en-US" sz="2000" dirty="0"/>
+          </a:p>
+          <a:p>
+            <a:pPr indent="0" marL="0">
+              <a:buNone/>
+            </a:pPr>
+            <a:r>
+              <a:rPr lang="en-US" sz="2000" dirty="0">
+                <a:solidFill>
+                  <a:srgbClr val="191919"/>
+                </a:solidFill>
+                <a:latin typeface="Arial" pitchFamily="34" charset="0"/>
+                <a:ea typeface="Arial" pitchFamily="34" charset="-122"/>
+                <a:cs typeface="Arial" pitchFamily="34" charset="-120"/>
+              </a:rPr>
+              <a:t>Explain a problem to someone who is not technical. Notice the small detail that breaks everything. Stay calm when the system is down.</a:t>
+            </a:r>
+            <a:endParaRPr lang="en-US" sz="2000" dirty="0"/>
+          </a:p>
+        </p:txBody>
+      </p:sp>
+      <p:sp>
+        <p:nvSpPr>
+          <p:cNvPr id="10" name="Text 8"/>
+          <p:cNvSpPr txBox="1"/>
+          <p:nvPr/>
+        </p:nvSpPr>
+        <p:spPr>
+          <a:xfrm>
+            <a:off x="609600" y="5048250"/>
+            <a:ext cx="10953750" cy="476250"/>
+          </a:xfrm>
+          <a:prstGeom prst="rect">
+            <a:avLst/>
+          </a:prstGeom>
+          <a:noFill/>
+          <a:ln/>
+        </p:spPr>
+        <p:txBody>
+          <a:bodyPr wrap="square" lIns="0" tIns="0" rIns="0" bIns="0" rtlCol="0" anchor="t"/>
+          <a:lstStyle/>
+          <a:p>
+            <a:pPr indent="0" marL="0">
+              <a:buNone/>
+            </a:pPr>
+            <a:r>
+              <a:rPr lang="en-US" sz="2200" b="1" dirty="0">
+                <a:solidFill>
+                  <a:srgbClr val="191919"/>
+                </a:solidFill>
+                <a:latin typeface="Arial" pitchFamily="34" charset="0"/>
+                <a:ea typeface="Arial" pitchFamily="34" charset="-122"/>
+                <a:cs typeface="Arial" pitchFamily="34" charset="-120"/>
+              </a:rPr>
+              <a:t>A technical skill gets you one job. A transferable skill goes with you to the next one.</a:t>
+            </a:r>
+            <a:endParaRPr lang="en-US" sz="2200" dirty="0"/>
           </a:p>
         </p:txBody>
       </p:sp>
@@ -5118,7 +5964,7 @@
                 <a:ea typeface="Arial Black" pitchFamily="34" charset="-122"/>
                 <a:cs typeface="Arial Black" pitchFamily="34" charset="-120"/>
               </a:rPr>
-              <a:t>Before you go</a:t>
+              <a:t>Stop and Jot</a:t>
             </a:r>
             <a:endParaRPr lang="en-US" sz="4200" dirty="0"/>
           </a:p>
@@ -5126,14 +5972,53 @@
       </p:sp>
       <p:sp>
         <p:nvSpPr>
-          <p:cNvPr id="3" name="Shape 1"/>
+          <p:cNvPr id="3" name="Text 1"/>
+          <p:cNvSpPr txBox="1"/>
+          <p:nvPr/>
+        </p:nvSpPr>
+        <p:spPr>
+          <a:xfrm>
+            <a:off x="628650" y="1295400"/>
+            <a:ext cx="10915650" cy="476250"/>
+          </a:xfrm>
+          <a:prstGeom prst="rect">
+            <a:avLst/>
+          </a:prstGeom>
+          <a:noFill/>
+          <a:ln/>
+        </p:spPr>
+        <p:txBody>
+          <a:bodyPr wrap="square" lIns="0" tIns="0" rIns="0" bIns="0" rtlCol="0" anchor="ctr"/>
+          <a:lstStyle/>
+          <a:p>
+            <a:pPr indent="0" marL="0">
+              <a:buNone/>
+            </a:pPr>
+            <a:r>
+              <a:rPr lang="en-US" sz="2100" dirty="0">
+                <a:solidFill>
+                  <a:srgbClr val="191919"/>
+                </a:solidFill>
+                <a:latin typeface="Arial" pitchFamily="34" charset="0"/>
+                <a:ea typeface="Arial" pitchFamily="34" charset="-122"/>
+                <a:cs typeface="Arial" pitchFamily="34" charset="-120"/>
+              </a:rPr>
+              <a:t>60 seconds · Voice 0 · In your notebook</a:t>
+            </a:r>
+            <a:endParaRPr lang="en-US" sz="2100" dirty="0"/>
+          </a:p>
+        </p:txBody>
+      </p:sp>
+      <p:sp>
+        <p:nvSpPr>
+          <p:cNvPr id="4" name="Shape 2"/>
           <p:cNvSpPr/>
           <p:nvPr/>
         </p:nvSpPr>
         <p:spPr>
           <a:xfrm>
-            <a:off x="609600" y="1952625"/>
-            <a:ext cx="10972800" cy="819150"/>
+            <a:off x="609600" y="1905000"/>
+            <a:ext cx="10972800" cy="1619250"/>
           </a:xfrm>
           <a:prstGeom prst="rect">
             <a:avLst/>
@@ -5151,39 +6036,70 @@
       </p:sp>
       <p:sp>
         <p:nvSpPr>
-          <p:cNvPr id="4" name="Shape 2"/>
-          <p:cNvSpPr/>
-          <p:nvPr/>
-        </p:nvSpPr>
-        <p:spPr>
-          <a:xfrm>
-            <a:off x="800100" y="2105025"/>
-            <a:ext cx="457200" cy="457200"/>
-          </a:xfrm>
-          <a:prstGeom prst="ellipse">
-            <a:avLst/>
-          </a:prstGeom>
-          <a:solidFill>
-            <a:srgbClr val="1955DB"/>
-          </a:solidFill>
-          <a:ln w="12700">
-            <a:solidFill>
-              <a:srgbClr val="1955DB"/>
-            </a:solidFill>
-            <a:prstDash val="solid"/>
-          </a:ln>
-        </p:spPr>
-      </p:sp>
-      <p:sp>
-        <p:nvSpPr>
           <p:cNvPr id="5" name="Text 3"/>
           <p:cNvSpPr txBox="1"/>
           <p:nvPr/>
         </p:nvSpPr>
         <p:spPr>
           <a:xfrm>
-            <a:off x="800100" y="2105025"/>
-            <a:ext cx="457200" cy="457200"/>
+            <a:off x="876300" y="2133600"/>
+            <a:ext cx="10477500" cy="1238250"/>
+          </a:xfrm>
+          <a:prstGeom prst="rect">
+            <a:avLst/>
+          </a:prstGeom>
+          <a:noFill/>
+          <a:ln/>
+        </p:spPr>
+        <p:txBody>
+          <a:bodyPr wrap="square" lIns="0" tIns="0" rIns="0" bIns="0" rtlCol="0" anchor="t"/>
+          <a:lstStyle/>
+          <a:p>
+            <a:pPr indent="0" marL="0">
+              <a:buNone/>
+            </a:pPr>
+            <a:r>
+              <a:rPr lang="en-US" sz="2600" b="1" dirty="0">
+                <a:solidFill>
+                  <a:srgbClr val="191919"/>
+                </a:solidFill>
+                <a:latin typeface="Arial" pitchFamily="34" charset="0"/>
+                <a:ea typeface="Arial" pitchFamily="34" charset="-122"/>
+                <a:cs typeface="Arial" pitchFamily="34" charset="-120"/>
+              </a:rPr>
+              <a:t>Pick a skill from your rows that TWO of the four careers need.</a:t>
+            </a:r>
+            <a:endParaRPr lang="en-US" sz="2600" dirty="0"/>
+          </a:p>
+          <a:p>
+            <a:pPr indent="0" marL="0">
+              <a:buNone/>
+            </a:pPr>
+            <a:r>
+              <a:rPr lang="en-US" sz="2600" b="1" dirty="0">
+                <a:solidFill>
+                  <a:srgbClr val="191919"/>
+                </a:solidFill>
+                <a:latin typeface="Arial" pitchFamily="34" charset="0"/>
+                <a:ea typeface="Arial" pitchFamily="34" charset="-122"/>
+                <a:cs typeface="Arial" pitchFamily="34" charset="-120"/>
+              </a:rPr>
+              <a:t>Write one complete sentence.</a:t>
+            </a:r>
+            <a:endParaRPr lang="en-US" sz="2600" dirty="0"/>
+          </a:p>
+        </p:txBody>
+      </p:sp>
+      <p:sp>
+        <p:nvSpPr>
+          <p:cNvPr id="6" name="Text 4"/>
+          <p:cNvSpPr txBox="1"/>
+          <p:nvPr/>
+        </p:nvSpPr>
+        <p:spPr>
+          <a:xfrm>
+            <a:off x="609600" y="3810000"/>
+            <a:ext cx="5715000" cy="400050"/>
           </a:xfrm>
           <a:prstGeom prst="rect">
             <a:avLst/>
@@ -5195,34 +6111,90 @@
           <a:bodyPr wrap="square" lIns="0" tIns="0" rIns="0" bIns="0" rtlCol="0" anchor="ctr"/>
           <a:lstStyle/>
           <a:p>
-            <a:pPr algn="ctr" indent="0" marL="0">
-              <a:buNone/>
-            </a:pPr>
-            <a:r>
-              <a:rPr lang="en-US" sz="2000" b="1" dirty="0">
-                <a:solidFill>
-                  <a:srgbClr val="FFFFFF"/>
+            <a:pPr indent="0" marL="0">
+              <a:buNone/>
+            </a:pPr>
+            <a:r>
+              <a:rPr lang="en-US" sz="2300" b="1" dirty="0">
+                <a:solidFill>
+                  <a:srgbClr val="1955DB"/>
                 </a:solidFill>
                 <a:latin typeface="Arial Black" pitchFamily="34" charset="0"/>
                 <a:ea typeface="Arial Black" pitchFamily="34" charset="-122"/>
                 <a:cs typeface="Arial Black" pitchFamily="34" charset="-120"/>
               </a:rPr>
-              <a:t>1</a:t>
-            </a:r>
-            <a:endParaRPr lang="en-US" sz="2000" dirty="0"/>
-          </a:p>
-        </p:txBody>
-      </p:sp>
-      <p:sp>
-        <p:nvSpPr>
-          <p:cNvPr id="6" name="Text 4"/>
-          <p:cNvSpPr txBox="1"/>
-          <p:nvPr/>
-        </p:nvSpPr>
-        <p:spPr>
-          <a:xfrm>
-            <a:off x="1447800" y="2066925"/>
-            <a:ext cx="9925050" cy="628650"/>
+              <a:t>Say it like this</a:t>
+            </a:r>
+            <a:endParaRPr lang="en-US" sz="2300" dirty="0"/>
+          </a:p>
+        </p:txBody>
+      </p:sp>
+      <p:sp>
+        <p:nvSpPr>
+          <p:cNvPr id="7" name="Text 5"/>
+          <p:cNvSpPr txBox="1"/>
+          <p:nvPr/>
+        </p:nvSpPr>
+        <p:spPr>
+          <a:xfrm>
+            <a:off x="609600" y="4248150"/>
+            <a:ext cx="10953750" cy="571500"/>
+          </a:xfrm>
+          <a:prstGeom prst="rect">
+            <a:avLst/>
+          </a:prstGeom>
+          <a:noFill/>
+          <a:ln/>
+        </p:spPr>
+        <p:txBody>
+          <a:bodyPr wrap="square" lIns="0" tIns="0" rIns="0" bIns="0" rtlCol="0" anchor="t"/>
+          <a:lstStyle/>
+          <a:p>
+            <a:pPr indent="0" marL="0">
+              <a:buNone/>
+            </a:pPr>
+            <a:r>
+              <a:rPr lang="en-US" sz="2400" dirty="0">
+                <a:solidFill>
+                  <a:srgbClr val="191919"/>
+                </a:solidFill>
+                <a:latin typeface="Arial" pitchFamily="34" charset="0"/>
+                <a:ea typeface="Arial" pitchFamily="34" charset="-122"/>
+                <a:cs typeface="Arial" pitchFamily="34" charset="-120"/>
+              </a:rPr>
+              <a:t>________ transfers across ________ and ________</a:t>
+            </a:r>
+            <a:endParaRPr lang="en-US" sz="2400" dirty="0"/>
+          </a:p>
+          <a:p>
+            <a:pPr indent="0" marL="0">
+              <a:buNone/>
+            </a:pPr>
+            <a:r>
+              <a:rPr lang="en-US" sz="2400" dirty="0">
+                <a:solidFill>
+                  <a:srgbClr val="191919"/>
+                </a:solidFill>
+                <a:latin typeface="Arial" pitchFamily="34" charset="0"/>
+                <a:ea typeface="Arial" pitchFamily="34" charset="-122"/>
+                <a:cs typeface="Arial" pitchFamily="34" charset="-120"/>
+              </a:rPr>
+              <a:t>because both workers must ________.</a:t>
+            </a:r>
+            <a:endParaRPr lang="en-US" sz="2400" dirty="0"/>
+          </a:p>
+        </p:txBody>
+      </p:sp>
+      <p:sp>
+        <p:nvSpPr>
+          <p:cNvPr id="8" name="Text 6"/>
+          <p:cNvSpPr txBox="1"/>
+          <p:nvPr/>
+        </p:nvSpPr>
+        <p:spPr>
+          <a:xfrm>
+            <a:off x="609600" y="5334000"/>
+            <a:ext cx="5715000" cy="400050"/>
           </a:xfrm>
           <a:prstGeom prst="rect">
             <a:avLst/>
@@ -5238,312 +6210,56 @@
               <a:buNone/>
             </a:pPr>
             <a:r>
-              <a:rPr lang="en-US" sz="2400" dirty="0">
-                <a:solidFill>
-                  <a:srgbClr val="191919"/>
-                </a:solidFill>
-                <a:latin typeface="Arial" pitchFamily="34" charset="0"/>
-                <a:ea typeface="Arial" pitchFamily="34" charset="-122"/>
-                <a:cs typeface="Arial" pitchFamily="34" charset="-120"/>
-              </a:rPr>
-              <a:t>Four rows done: a task and a skill for each career.</a:t>
-            </a:r>
-            <a:endParaRPr lang="en-US" sz="2400" dirty="0"/>
-          </a:p>
-        </p:txBody>
-      </p:sp>
-      <p:sp>
-        <p:nvSpPr>
-          <p:cNvPr id="7" name="Shape 5"/>
-          <p:cNvSpPr/>
-          <p:nvPr/>
-        </p:nvSpPr>
-        <p:spPr>
-          <a:xfrm>
-            <a:off x="609600" y="2905125"/>
-            <a:ext cx="10972800" cy="819150"/>
-          </a:xfrm>
-          <a:prstGeom prst="rect">
-            <a:avLst/>
-          </a:prstGeom>
-          <a:solidFill>
-            <a:srgbClr val="FFFFFF"/>
-          </a:solidFill>
-          <a:ln w="12700">
-            <a:solidFill>
-              <a:srgbClr val="FFFFFF"/>
-            </a:solidFill>
-            <a:prstDash val="solid"/>
-          </a:ln>
-        </p:spPr>
-      </p:sp>
-      <p:sp>
-        <p:nvSpPr>
-          <p:cNvPr id="8" name="Shape 6"/>
-          <p:cNvSpPr/>
-          <p:nvPr/>
-        </p:nvSpPr>
-        <p:spPr>
-          <a:xfrm>
-            <a:off x="800100" y="3057525"/>
-            <a:ext cx="457200" cy="457200"/>
-          </a:xfrm>
-          <a:prstGeom prst="ellipse">
-            <a:avLst/>
-          </a:prstGeom>
-          <a:solidFill>
-            <a:srgbClr val="1955DB"/>
-          </a:solidFill>
-          <a:ln w="12700">
-            <a:solidFill>
-              <a:srgbClr val="1955DB"/>
-            </a:solidFill>
-            <a:prstDash val="solid"/>
-          </a:ln>
-        </p:spPr>
-      </p:sp>
-      <p:sp>
-        <p:nvSpPr>
-          <p:cNvPr id="9" name="Text 7"/>
-          <p:cNvSpPr txBox="1"/>
-          <p:nvPr/>
-        </p:nvSpPr>
-        <p:spPr>
-          <a:xfrm>
-            <a:off x="800100" y="3057525"/>
-            <a:ext cx="457200" cy="457200"/>
-          </a:xfrm>
-          <a:prstGeom prst="rect">
-            <a:avLst/>
-          </a:prstGeom>
-          <a:noFill/>
-          <a:ln/>
-        </p:spPr>
-        <p:txBody>
-          <a:bodyPr wrap="square" lIns="0" tIns="0" rIns="0" bIns="0" rtlCol="0" anchor="ctr"/>
-          <a:lstStyle/>
-          <a:p>
-            <a:pPr algn="ctr" indent="0" marL="0">
-              <a:buNone/>
-            </a:pPr>
-            <a:r>
-              <a:rPr lang="en-US" sz="2000" b="1" dirty="0">
-                <a:solidFill>
-                  <a:srgbClr val="FFFFFF"/>
+              <a:rPr lang="en-US" sz="2300" b="1" dirty="0">
+                <a:solidFill>
+                  <a:srgbClr val="1955DB"/>
                 </a:solidFill>
                 <a:latin typeface="Arial Black" pitchFamily="34" charset="0"/>
                 <a:ea typeface="Arial Black" pitchFamily="34" charset="-122"/>
                 <a:cs typeface="Arial Black" pitchFamily="34" charset="-120"/>
               </a:rPr>
-              <a:t>2</a:t>
+              <a:t>Words you will need</a:t>
+            </a:r>
+            <a:endParaRPr lang="en-US" sz="2300" dirty="0"/>
+          </a:p>
+        </p:txBody>
+      </p:sp>
+      <p:sp>
+        <p:nvSpPr>
+          <p:cNvPr id="9" name="Text 7"/>
+          <p:cNvSpPr txBox="1"/>
+          <p:nvPr/>
+        </p:nvSpPr>
+        <p:spPr>
+          <a:xfrm>
+            <a:off x="609600" y="5772150"/>
+            <a:ext cx="10953750" cy="476250"/>
+          </a:xfrm>
+          <a:prstGeom prst="rect">
+            <a:avLst/>
+          </a:prstGeom>
+          <a:noFill/>
+          <a:ln/>
+        </p:spPr>
+        <p:txBody>
+          <a:bodyPr wrap="square" lIns="0" tIns="0" rIns="0" bIns="0" rtlCol="0" anchor="t"/>
+          <a:lstStyle/>
+          <a:p>
+            <a:pPr indent="0" marL="0">
+              <a:buNone/>
+            </a:pPr>
+            <a:r>
+              <a:rPr lang="en-US" sz="2000" dirty="0">
+                <a:solidFill>
+                  <a:srgbClr val="191919"/>
+                </a:solidFill>
+                <a:latin typeface="Arial" pitchFamily="34" charset="0"/>
+                <a:ea typeface="Arial" pitchFamily="34" charset="-122"/>
+                <a:cs typeface="Arial" pitchFamily="34" charset="-120"/>
+              </a:rPr>
+              <a:t>problem-solving  ·  communication  ·  attention to detail  ·  time management  ·  teamwork  ·  curiosity  ·  patience under pressure</a:t>
             </a:r>
             <a:endParaRPr lang="en-US" sz="2000" dirty="0"/>
-          </a:p>
-        </p:txBody>
-      </p:sp>
-      <p:sp>
-        <p:nvSpPr>
-          <p:cNvPr id="10" name="Text 8"/>
-          <p:cNvSpPr txBox="1"/>
-          <p:nvPr/>
-        </p:nvSpPr>
-        <p:spPr>
-          <a:xfrm>
-            <a:off x="1447800" y="3019425"/>
-            <a:ext cx="9925050" cy="628650"/>
-          </a:xfrm>
-          <a:prstGeom prst="rect">
-            <a:avLst/>
-          </a:prstGeom>
-          <a:noFill/>
-          <a:ln/>
-        </p:spPr>
-        <p:txBody>
-          <a:bodyPr wrap="square" lIns="0" tIns="0" rIns="0" bIns="0" rtlCol="0" anchor="ctr"/>
-          <a:lstStyle/>
-          <a:p>
-            <a:pPr indent="0" marL="0">
-              <a:buNone/>
-            </a:pPr>
-            <a:r>
-              <a:rPr lang="en-US" sz="2400" dirty="0">
-                <a:solidFill>
-                  <a:srgbClr val="191919"/>
-                </a:solidFill>
-                <a:latin typeface="Arial" pitchFamily="34" charset="0"/>
-                <a:ea typeface="Arial" pitchFamily="34" charset="-122"/>
-                <a:cs typeface="Arial" pitchFamily="34" charset="-120"/>
-              </a:rPr>
-              <a:t>Your Stop and Jot sentence in your notebook.</a:t>
-            </a:r>
-            <a:endParaRPr lang="en-US" sz="2400" dirty="0"/>
-          </a:p>
-        </p:txBody>
-      </p:sp>
-      <p:sp>
-        <p:nvSpPr>
-          <p:cNvPr id="11" name="Shape 9"/>
-          <p:cNvSpPr/>
-          <p:nvPr/>
-        </p:nvSpPr>
-        <p:spPr>
-          <a:xfrm>
-            <a:off x="609600" y="3857625"/>
-            <a:ext cx="10972800" cy="819150"/>
-          </a:xfrm>
-          <a:prstGeom prst="rect">
-            <a:avLst/>
-          </a:prstGeom>
-          <a:solidFill>
-            <a:srgbClr val="FFFFFF"/>
-          </a:solidFill>
-          <a:ln w="12700">
-            <a:solidFill>
-              <a:srgbClr val="FFFFFF"/>
-            </a:solidFill>
-            <a:prstDash val="solid"/>
-          </a:ln>
-        </p:spPr>
-      </p:sp>
-      <p:sp>
-        <p:nvSpPr>
-          <p:cNvPr id="12" name="Shape 10"/>
-          <p:cNvSpPr/>
-          <p:nvPr/>
-        </p:nvSpPr>
-        <p:spPr>
-          <a:xfrm>
-            <a:off x="800100" y="4010025"/>
-            <a:ext cx="457200" cy="457200"/>
-          </a:xfrm>
-          <a:prstGeom prst="ellipse">
-            <a:avLst/>
-          </a:prstGeom>
-          <a:solidFill>
-            <a:srgbClr val="1955DB"/>
-          </a:solidFill>
-          <a:ln w="12700">
-            <a:solidFill>
-              <a:srgbClr val="1955DB"/>
-            </a:solidFill>
-            <a:prstDash val="solid"/>
-          </a:ln>
-        </p:spPr>
-      </p:sp>
-      <p:sp>
-        <p:nvSpPr>
-          <p:cNvPr id="13" name="Text 11"/>
-          <p:cNvSpPr txBox="1"/>
-          <p:nvPr/>
-        </p:nvSpPr>
-        <p:spPr>
-          <a:xfrm>
-            <a:off x="800100" y="4010025"/>
-            <a:ext cx="457200" cy="457200"/>
-          </a:xfrm>
-          <a:prstGeom prst="rect">
-            <a:avLst/>
-          </a:prstGeom>
-          <a:noFill/>
-          <a:ln/>
-        </p:spPr>
-        <p:txBody>
-          <a:bodyPr wrap="square" lIns="0" tIns="0" rIns="0" bIns="0" rtlCol="0" anchor="ctr"/>
-          <a:lstStyle/>
-          <a:p>
-            <a:pPr algn="ctr" indent="0" marL="0">
-              <a:buNone/>
-            </a:pPr>
-            <a:r>
-              <a:rPr lang="en-US" sz="2000" b="1" dirty="0">
-                <a:solidFill>
-                  <a:srgbClr val="FFFFFF"/>
-                </a:solidFill>
-                <a:latin typeface="Arial Black" pitchFamily="34" charset="0"/>
-                <a:ea typeface="Arial Black" pitchFamily="34" charset="-122"/>
-                <a:cs typeface="Arial Black" pitchFamily="34" charset="-120"/>
-              </a:rPr>
-              <a:t>3</a:t>
-            </a:r>
-            <a:endParaRPr lang="en-US" sz="2000" dirty="0"/>
-          </a:p>
-        </p:txBody>
-      </p:sp>
-      <p:sp>
-        <p:nvSpPr>
-          <p:cNvPr id="14" name="Text 12"/>
-          <p:cNvSpPr txBox="1"/>
-          <p:nvPr/>
-        </p:nvSpPr>
-        <p:spPr>
-          <a:xfrm>
-            <a:off x="1447800" y="3971925"/>
-            <a:ext cx="9925050" cy="628650"/>
-          </a:xfrm>
-          <a:prstGeom prst="rect">
-            <a:avLst/>
-          </a:prstGeom>
-          <a:noFill/>
-          <a:ln/>
-        </p:spPr>
-        <p:txBody>
-          <a:bodyPr wrap="square" lIns="0" tIns="0" rIns="0" bIns="0" rtlCol="0" anchor="ctr"/>
-          <a:lstStyle/>
-          <a:p>
-            <a:pPr indent="0" marL="0">
-              <a:buNone/>
-            </a:pPr>
-            <a:r>
-              <a:rPr lang="en-US" sz="2400" dirty="0">
-                <a:solidFill>
-                  <a:srgbClr val="191919"/>
-                </a:solidFill>
-                <a:latin typeface="Arial" pitchFamily="34" charset="0"/>
-                <a:ea typeface="Arial" pitchFamily="34" charset="-122"/>
-                <a:cs typeface="Arial" pitchFamily="34" charset="-120"/>
-              </a:rPr>
-              <a:t>Exit ticket submitted.</a:t>
-            </a:r>
-            <a:endParaRPr lang="en-US" sz="2400" dirty="0"/>
-          </a:p>
-        </p:txBody>
-      </p:sp>
-      <p:sp>
-        <p:nvSpPr>
-          <p:cNvPr id="15" name="Text 13"/>
-          <p:cNvSpPr txBox="1"/>
-          <p:nvPr/>
-        </p:nvSpPr>
-        <p:spPr>
-          <a:xfrm>
-            <a:off x="609600" y="5143500"/>
-            <a:ext cx="10953750" cy="571500"/>
-          </a:xfrm>
-          <a:prstGeom prst="rect">
-            <a:avLst/>
-          </a:prstGeom>
-          <a:noFill/>
-          <a:ln/>
-        </p:spPr>
-        <p:txBody>
-          <a:bodyPr wrap="square" lIns="0" tIns="0" rIns="0" bIns="0" rtlCol="0" anchor="t"/>
-          <a:lstStyle/>
-          <a:p>
-            <a:pPr indent="0" marL="0">
-              <a:buNone/>
-            </a:pPr>
-            <a:r>
-              <a:rPr lang="en-US" sz="2200" b="1" dirty="0">
-                <a:solidFill>
-                  <a:srgbClr val="191919"/>
-                </a:solidFill>
-                <a:latin typeface="Arial" pitchFamily="34" charset="0"/>
-                <a:ea typeface="Arial" pitchFamily="34" charset="-122"/>
-                <a:cs typeface="Arial" pitchFamily="34" charset="-120"/>
-              </a:rPr>
-              <a:t>Tomorrow: you become a UX designer and audit a real website. Bring your Find Your Future workbook.</a:t>
-            </a:r>
-            <a:endParaRPr lang="en-US" sz="2200" dirty="0"/>
           </a:p>
         </p:txBody>
       </p:sp>

</xml_diff>